<commit_message>
Add a source and date footer to the 15 Oct carousel and simplify Post 4
Co-Authored-By: Claude Opus 5.5 <noreply@anthropic.com>
Claude-Session: https://claude.ai/code/session_01SNf1Edf2HMYqmZpheYf6i6
</commit_message>
<xml_diff>
--- a/emyaa-ceo-deck/output/content-calendar/Content_Calendar_OCT_2026_V3_-_eMYAA.pptx
+++ b/emyaa-ceo-deck/output/content-calendar/Content_Calendar_OCT_2026_V3_-_eMYAA.pptx
@@ -25132,7 +25132,7 @@
           </a:ln>
         </p:spPr>
         <p:txBody>
-          <a:bodyPr spcFirstLastPara="1" wrap="square" lIns="0" tIns="0" rIns="0" bIns="0" anchor="ctr" anchorCtr="0">
+          <a:bodyPr spcFirstLastPara="1" wrap="square" lIns="0" tIns="0" rIns="0" bIns="0" anchor="t" anchorCtr="0">
             <a:spAutoFit/>
           </a:bodyPr>
           <a:lstStyle/>
@@ -25155,7 +25155,7 @@
               <a:buNone/>
             </a:pPr>
             <a:r>
-              <a:rPr lang="en-US" sz="1300" b="0" i="0" u="none" strike="noStrike" cap="none" dirty="0" err="1">
+              <a:rPr lang="en-US" sz="1150" b="0" i="0" u="none" strike="noStrike" cap="none" dirty="0" err="1">
                 <a:solidFill>
                   <a:schemeClr val="dk1"/>
                 </a:solidFill>
@@ -25167,7 +25167,7 @@
               <a:t>البوست</a:t>
             </a:r>
             <a:r>
-              <a:rPr lang="en-US" sz="1300" b="0" i="0" u="none" strike="noStrike" cap="none" dirty="0">
+              <a:rPr lang="en-US" sz="1150" b="0" i="0" u="none" strike="noStrike" cap="none" dirty="0">
                 <a:solidFill>
                   <a:schemeClr val="dk1"/>
                 </a:solidFill>
@@ -25179,7 +25179,7 @@
               <a:t> </a:t>
             </a:r>
             <a:r>
-              <a:rPr lang="en-US" sz="1300" b="0" i="0" u="none" strike="noStrike" cap="none" dirty="0" err="1">
+              <a:rPr lang="en-US" sz="1150" b="0" i="0" u="none" strike="noStrike" cap="none" dirty="0" err="1">
                 <a:solidFill>
                   <a:schemeClr val="dk1"/>
                 </a:solidFill>
@@ -25191,7 +25191,7 @@
               <a:t>الأول</a:t>
             </a:r>
             <a:r>
-              <a:rPr lang="en-US" sz="1300" b="0" i="0" u="none" strike="noStrike" cap="none" dirty="0">
+              <a:rPr lang="en-US" sz="1150" b="0" i="0" u="none" strike="noStrike" cap="none" dirty="0">
                 <a:solidFill>
                   <a:schemeClr val="dk1"/>
                 </a:solidFill>
@@ -25231,7 +25231,7 @@
               <a:buNone/>
             </a:pPr>
             <a:r>
-              <a:rPr lang="en-US" sz="1300" b="0" i="0" u="none" strike="noStrike" cap="none" dirty="0" err="1">
+              <a:rPr lang="en-US" sz="1150" b="0" i="0" u="none" strike="noStrike" cap="none" dirty="0" err="1">
                 <a:solidFill>
                   <a:schemeClr val="dk1"/>
                 </a:solidFill>
@@ -25299,7 +25299,7 @@
               <a:buNone/>
             </a:pPr>
             <a:r>
-              <a:rPr lang="en-US" sz="1300" b="0" i="0" u="none" strike="noStrike" cap="none" dirty="0" err="1">
+              <a:rPr lang="en-US" sz="1150" b="0" i="0" u="none" strike="noStrike" cap="none" dirty="0" err="1">
                 <a:solidFill>
                   <a:schemeClr val="dk1"/>
                 </a:solidFill>
@@ -25311,7 +25311,7 @@
               <a:t>البوست</a:t>
             </a:r>
             <a:r>
-              <a:rPr lang="en-US" sz="1300" b="0" i="0" u="none" strike="noStrike" cap="none" dirty="0">
+              <a:rPr lang="en-US" sz="1150" b="0" i="0" u="none" strike="noStrike" cap="none" dirty="0">
                 <a:solidFill>
                   <a:schemeClr val="dk1"/>
                 </a:solidFill>
@@ -25323,7 +25323,7 @@
               <a:t> </a:t>
             </a:r>
             <a:r>
-              <a:rPr lang="en-US" sz="1300" b="0" i="0" u="none" strike="noStrike" cap="none" dirty="0" err="1">
+              <a:rPr lang="en-US" sz="1150" b="0" i="0" u="none" strike="noStrike" cap="none" dirty="0" err="1">
                 <a:solidFill>
                   <a:schemeClr val="dk1"/>
                 </a:solidFill>
@@ -25335,7 +25335,7 @@
               <a:t>الثاني</a:t>
             </a:r>
             <a:r>
-              <a:rPr lang="en-US" sz="1300" b="0" i="0" u="none" strike="noStrike" cap="none" dirty="0">
+              <a:rPr lang="en-US" sz="1150" b="0" i="0" u="none" strike="noStrike" cap="none" dirty="0">
                 <a:solidFill>
                   <a:schemeClr val="dk1"/>
                 </a:solidFill>
@@ -25375,7 +25375,7 @@
               <a:buNone/>
             </a:pPr>
             <a:r>
-              <a:rPr lang="en-US" sz="1300" b="0" i="0" u="none" strike="noStrike" cap="none" dirty="0" err="1">
+              <a:rPr lang="en-US" sz="1150" b="0" i="0" u="none" strike="noStrike" cap="none" dirty="0" err="1">
                 <a:solidFill>
                   <a:schemeClr val="dk1"/>
                 </a:solidFill>
@@ -25415,7 +25415,7 @@
               <a:buNone/>
             </a:pPr>
             <a:r>
-              <a:rPr lang="en-US" sz="1300" b="0" i="0" u="none" strike="noStrike" cap="none" dirty="0" err="1">
+              <a:rPr lang="en-US" sz="1150" b="0" i="0" u="none" strike="noStrike" cap="none" dirty="0" err="1">
                 <a:solidFill>
                   <a:schemeClr val="dk1"/>
                 </a:solidFill>
@@ -25454,18 +25454,6 @@
               <a:buFont typeface="Arial"/>
               <a:buNone/>
             </a:pPr>
-            <a:r>
-              <a:rPr lang="en-US" sz="1300" b="0" i="1" u="none" strike="noStrike" cap="none" dirty="0" err="1">
-                <a:solidFill>
-                  <a:schemeClr val="dk1"/>
-                </a:solidFill>
-                <a:latin typeface="Rubik"/>
-                <a:ea typeface="Rubik"/>
-                <a:cs typeface="Rubik"/>
-                <a:sym typeface="Rubik"/>
-              </a:rPr>
-              <a:t>المصدر: SIFMA - Capital Markets Fact Book 2026</a:t>
-            </a:r>
             <a:endParaRPr sz="1300" b="0" i="0" u="none" strike="noStrike" cap="none" dirty="0">
               <a:solidFill>
                 <a:schemeClr val="dk1"/>
@@ -25490,10 +25478,182 @@
               <a:buClr>
                 <a:schemeClr val="dk1"/>
               </a:buClr>
+              <a:buSzPts val="974"/>
+              <a:buFont typeface="Arial"/>
+              <a:buNone/>
+            </a:pPr>
+            <a:r>
+              <a:rPr lang="en-US" sz="1150" b="0" i="0" u="none" strike="noStrike" cap="none" dirty="0" err="1">
+                <a:solidFill>
+                  <a:schemeClr val="dk1"/>
+                </a:solidFill>
+                <a:latin typeface="Rubik Medium"/>
+                <a:ea typeface="Rubik Medium"/>
+                <a:cs typeface="Rubik Medium"/>
+                <a:sym typeface="Rubik Medium"/>
+              </a:rPr>
+              <a:t>البوست</a:t>
+            </a:r>
+            <a:r>
+              <a:rPr lang="en-US" sz="1150" b="0" i="0" u="none" strike="noStrike" cap="none" dirty="0">
+                <a:solidFill>
+                  <a:schemeClr val="dk1"/>
+                </a:solidFill>
+                <a:latin typeface="Rubik Medium"/>
+                <a:ea typeface="Rubik Medium"/>
+                <a:cs typeface="Rubik Medium"/>
+                <a:sym typeface="Rubik Medium"/>
+              </a:rPr>
+              <a:t> </a:t>
+            </a:r>
+            <a:r>
+              <a:rPr lang="en-US" sz="1150" b="0" i="0" u="none" strike="noStrike" cap="none" dirty="0" err="1">
+                <a:solidFill>
+                  <a:schemeClr val="dk1"/>
+                </a:solidFill>
+                <a:latin typeface="Rubik Medium"/>
+                <a:ea typeface="Rubik Medium"/>
+                <a:cs typeface="Rubik Medium"/>
+                <a:sym typeface="Rubik Medium"/>
+              </a:rPr>
+              <a:t>الثالث</a:t>
+            </a:r>
+            <a:r>
+              <a:rPr lang="en-US" sz="1150" b="0" i="0" u="none" strike="noStrike" cap="none" dirty="0">
+                <a:solidFill>
+                  <a:schemeClr val="dk1"/>
+                </a:solidFill>
+                <a:latin typeface="Rubik Medium"/>
+                <a:ea typeface="Rubik Medium"/>
+                <a:cs typeface="Rubik Medium"/>
+                <a:sym typeface="Rubik Medium"/>
+              </a:rPr>
+              <a:t>: </a:t>
+            </a:r>
+            <a:endParaRPr sz="1300" b="0" i="0" u="none" strike="noStrike" cap="none" dirty="0">
+              <a:solidFill>
+                <a:schemeClr val="dk1"/>
+              </a:solidFill>
+              <a:latin typeface="Montserrat SemiBold"/>
+              <a:ea typeface="Montserrat SemiBold"/>
+              <a:cs typeface="Montserrat SemiBold"/>
+              <a:sym typeface="Montserrat SemiBold"/>
+            </a:endParaRPr>
+          </a:p>
+          <a:p>
+            <a:pPr marL="0" marR="0" lvl="0" indent="0" algn="r" rtl="1">
+              <a:lnSpc>
+                <a:spcPct val="115000"/>
+              </a:lnSpc>
+              <a:spcBef>
+                <a:spcPts val="0"/>
+              </a:spcBef>
+              <a:spcAft>
+                <a:spcPts val="0"/>
+              </a:spcAft>
+              <a:buClr>
+                <a:schemeClr val="dk1"/>
+              </a:buClr>
               <a:buSzPts val="1100"/>
               <a:buFont typeface="Arial"/>
               <a:buNone/>
             </a:pPr>
+            <a:r>
+              <a:rPr lang="en-US" sz="1150" b="0" i="0" u="none" strike="noStrike" cap="none" dirty="0" err="1">
+                <a:solidFill>
+                  <a:schemeClr val="dk1"/>
+                </a:solidFill>
+                <a:latin typeface="Rubik"/>
+                <a:ea typeface="Rubik"/>
+                <a:cs typeface="Rubik"/>
+                <a:sym typeface="Rubik"/>
+              </a:rPr>
+              <a:t>قوة</a:t>
+            </a:r>
+            <a:r>
+              <a:rPr lang="en-US" sz="1150" b="0" i="0" u="none" strike="noStrike" cap="none" dirty="0">
+                <a:solidFill>
+                  <a:schemeClr val="dk1"/>
+                </a:solidFill>
+                <a:latin typeface="Rubik"/>
+                <a:ea typeface="Rubik"/>
+                <a:cs typeface="Rubik"/>
+                <a:sym typeface="Rubik"/>
+              </a:rPr>
+              <a:t> </a:t>
+            </a:r>
+            <a:r>
+              <a:rPr lang="en-US" sz="1150" b="0" i="0" u="none" strike="noStrike" cap="none" dirty="0" err="1">
+                <a:solidFill>
+                  <a:schemeClr val="dk1"/>
+                </a:solidFill>
+                <a:latin typeface="Rubik"/>
+                <a:ea typeface="Rubik"/>
+                <a:cs typeface="Rubik"/>
+                <a:sym typeface="Rubik"/>
+              </a:rPr>
+              <a:t>مالية</a:t>
+            </a:r>
+            <a:r>
+              <a:rPr lang="en-US" sz="1150" b="0" i="0" u="none" strike="noStrike" cap="none" dirty="0">
+                <a:solidFill>
+                  <a:schemeClr val="dk1"/>
+                </a:solidFill>
+                <a:latin typeface="Rubik"/>
+                <a:ea typeface="Rubik"/>
+                <a:cs typeface="Rubik"/>
+                <a:sym typeface="Rubik"/>
+              </a:rPr>
+              <a:t> </a:t>
+            </a:r>
+            <a:r>
+              <a:rPr lang="en-US" sz="1150" b="0" i="0" u="none" strike="noStrike" cap="none" dirty="0" err="1">
+                <a:solidFill>
+                  <a:schemeClr val="dk1"/>
+                </a:solidFill>
+                <a:latin typeface="Rubik"/>
+                <a:ea typeface="Rubik"/>
+                <a:cs typeface="Rubik"/>
+                <a:sym typeface="Rubik"/>
+              </a:rPr>
+              <a:t>لا</a:t>
+            </a:r>
+            <a:r>
+              <a:rPr lang="en-US" sz="1150" b="0" i="0" u="none" strike="noStrike" cap="none" dirty="0">
+                <a:solidFill>
+                  <a:schemeClr val="dk1"/>
+                </a:solidFill>
+                <a:latin typeface="Rubik"/>
+                <a:ea typeface="Rubik"/>
+                <a:cs typeface="Rubik"/>
+                <a:sym typeface="Rubik"/>
+              </a:rPr>
+              <a:t> </a:t>
+            </a:r>
+            <a:r>
+              <a:rPr lang="en-US" sz="1150" b="0" i="0" u="none" strike="noStrike" cap="none" dirty="0" err="1">
+                <a:solidFill>
+                  <a:schemeClr val="dk1"/>
+                </a:solidFill>
+                <a:latin typeface="Rubik"/>
+                <a:ea typeface="Rubik"/>
+                <a:cs typeface="Rubik"/>
+                <a:sym typeface="Rubik"/>
+              </a:rPr>
+              <a:t>تُضاهى</a:t>
+            </a:r>
+            <a:r>
+              <a:rPr lang="en-US" sz="1150" b="0" i="0" u="none" strike="noStrike" cap="none" dirty="0">
+                <a:solidFill>
+                  <a:schemeClr val="dk1"/>
+                </a:solidFill>
+                <a:latin typeface="Rubik"/>
+                <a:ea typeface="Rubik"/>
+                <a:cs typeface="Rubik"/>
+                <a:sym typeface="Rubik"/>
+              </a:rPr>
+              <a:t> 💰</a:t>
+            </a:r>
             <a:endParaRPr sz="1300" b="0" i="0" u="none" strike="noStrike" cap="none" dirty="0">
               <a:solidFill>
                 <a:schemeClr val="dk1"/>
@@ -25518,12 +25678,80 @@
               <a:buClr>
                 <a:schemeClr val="dk1"/>
               </a:buClr>
+              <a:buSzPts val="1100"/>
+              <a:buFont typeface="Arial"/>
+              <a:buNone/>
+            </a:pPr>
+            <a:r>
+              <a:rPr lang="en-US" sz="1150" b="0" i="0" u="none" strike="noStrike" cap="none" dirty="0" err="1">
+                <a:solidFill>
+                  <a:schemeClr val="dk1"/>
+                </a:solidFill>
+                <a:latin typeface="Rubik"/>
+                <a:ea typeface="Rubik"/>
+                <a:cs typeface="Rubik"/>
+                <a:sym typeface="Rubik"/>
+              </a:rPr>
+              <a:t>بلغت القيمة السوقية لأسواق الأسهم الأمريكية 68.9 تريليون دولار في العام الماضي، أي ما يعادل 4.4 أضعاف حجم السوق الصينية، ثاني أكبر سوق أسهم في العالم.</a:t>
+            </a:r>
+            <a:endParaRPr sz="1300" b="0" i="0" u="none" strike="noStrike" cap="none" dirty="0">
+              <a:solidFill>
+                <a:schemeClr val="dk1"/>
+              </a:solidFill>
+              <a:latin typeface="Rubik"/>
+              <a:ea typeface="Rubik"/>
+              <a:cs typeface="Rubik"/>
+              <a:sym typeface="Rubik"/>
+            </a:endParaRPr>
+          </a:p>
+          <a:p>
+            <a:pPr marL="0" marR="0" lvl="0" indent="0" algn="r" rtl="1">
+              <a:lnSpc>
+                <a:spcPct val="115000"/>
+              </a:lnSpc>
+              <a:spcBef>
+                <a:spcPts val="0"/>
+              </a:spcBef>
+              <a:spcAft>
+                <a:spcPts val="0"/>
+              </a:spcAft>
+              <a:buClr>
+                <a:schemeClr val="dk1"/>
+              </a:buClr>
+              <a:buSzPts val="1100"/>
+              <a:buFont typeface="Arial"/>
+              <a:buNone/>
+            </a:pPr>
+            <a:endParaRPr sz="1300" b="0" i="1" u="none" strike="noStrike" cap="none" dirty="0">
+              <a:solidFill>
+                <a:schemeClr val="dk1"/>
+              </a:solidFill>
+              <a:latin typeface="Rubik"/>
+              <a:ea typeface="Rubik"/>
+              <a:cs typeface="Rubik"/>
+              <a:sym typeface="Rubik"/>
+            </a:endParaRPr>
+          </a:p>
+          <a:p>
+            <a:pPr marL="0" marR="0" lvl="0" indent="0" algn="r" rtl="1">
+              <a:lnSpc>
+                <a:spcPct val="115000"/>
+              </a:lnSpc>
+              <a:spcBef>
+                <a:spcPts val="0"/>
+              </a:spcBef>
+              <a:spcAft>
+                <a:spcPts val="0"/>
+              </a:spcAft>
+              <a:buClr>
+                <a:schemeClr val="dk1"/>
+              </a:buClr>
               <a:buSzPts val="974"/>
               <a:buFont typeface="Arial"/>
               <a:buNone/>
             </a:pPr>
             <a:r>
-              <a:rPr lang="en-US" sz="1300" b="0" i="0" u="none" strike="noStrike" cap="none" dirty="0" err="1">
+              <a:rPr lang="en-US" sz="1150" b="0" i="0" u="none" strike="noStrike" cap="none" dirty="0" err="1">
                 <a:solidFill>
                   <a:schemeClr val="dk1"/>
                 </a:solidFill>
@@ -25535,7 +25763,7 @@
               <a:t>البوست</a:t>
             </a:r>
             <a:r>
-              <a:rPr lang="en-US" sz="1300" b="0" i="0" u="none" strike="noStrike" cap="none" dirty="0">
+              <a:rPr lang="en-US" sz="1150" b="0" i="0" u="none" strike="noStrike" cap="none" dirty="0">
                 <a:solidFill>
                   <a:schemeClr val="dk1"/>
                 </a:solidFill>
@@ -25547,7 +25775,7 @@
               <a:t> </a:t>
             </a:r>
             <a:r>
-              <a:rPr lang="en-US" sz="1300" b="0" i="0" u="none" strike="noStrike" cap="none" dirty="0" err="1">
+              <a:rPr lang="en-US" sz="1150" b="0" i="0" u="none" strike="noStrike" cap="none" dirty="0" err="1">
                 <a:solidFill>
                   <a:schemeClr val="dk1"/>
                 </a:solidFill>
@@ -25556,10 +25784,10 @@
                 <a:cs typeface="Rubik Medium"/>
                 <a:sym typeface="Rubik Medium"/>
               </a:rPr>
-              <a:t>الثالث</a:t>
-            </a:r>
-            <a:r>
-              <a:rPr lang="en-US" sz="1300" b="0" i="0" u="none" strike="noStrike" cap="none" dirty="0">
+              <a:t>الرابع</a:t>
+            </a:r>
+            <a:r>
+              <a:rPr lang="en-US" sz="1150" b="0" i="0" u="none" strike="noStrike" cap="none" dirty="0">
                 <a:solidFill>
                   <a:schemeClr val="dk1"/>
                 </a:solidFill>
@@ -25599,19 +25827,19 @@
               <a:buNone/>
             </a:pPr>
             <a:r>
-              <a:rPr lang="en-US" sz="1300" b="0" i="0" u="none" strike="noStrike" cap="none" dirty="0" err="1">
-                <a:solidFill>
-                  <a:schemeClr val="dk1"/>
-                </a:solidFill>
-                <a:latin typeface="Rubik"/>
-                <a:ea typeface="Rubik"/>
-                <a:cs typeface="Rubik"/>
-                <a:sym typeface="Rubik"/>
-              </a:rPr>
-              <a:t>قوة</a:t>
-            </a:r>
-            <a:r>
-              <a:rPr lang="en-US" sz="1300" b="0" i="0" u="none" strike="noStrike" cap="none" dirty="0">
+              <a:rPr lang="en-US" sz="1150" b="0" i="0" u="none" strike="noStrike" cap="none" dirty="0" err="1">
+                <a:solidFill>
+                  <a:schemeClr val="dk1"/>
+                </a:solidFill>
+                <a:latin typeface="Rubik"/>
+                <a:ea typeface="Rubik"/>
+                <a:cs typeface="Rubik"/>
+                <a:sym typeface="Rubik"/>
+              </a:rPr>
+              <a:t>خيارات</a:t>
+            </a:r>
+            <a:r>
+              <a:rPr lang="en-US" sz="1150" b="0" i="0" u="none" strike="noStrike" cap="none" dirty="0">
                 <a:solidFill>
                   <a:schemeClr val="dk1"/>
                 </a:solidFill>
@@ -25623,19 +25851,19 @@
               <a:t> </a:t>
             </a:r>
             <a:r>
-              <a:rPr lang="en-US" sz="1300" b="0" i="0" u="none" strike="noStrike" cap="none" dirty="0" err="1">
-                <a:solidFill>
-                  <a:schemeClr val="dk1"/>
-                </a:solidFill>
-                <a:latin typeface="Rubik"/>
-                <a:ea typeface="Rubik"/>
-                <a:cs typeface="Rubik"/>
-                <a:sym typeface="Rubik"/>
-              </a:rPr>
-              <a:t>مالية</a:t>
-            </a:r>
-            <a:r>
-              <a:rPr lang="en-US" sz="1300" b="0" i="0" u="none" strike="noStrike" cap="none" dirty="0">
+              <a:rPr lang="en-US" sz="1150" b="0" i="0" u="none" strike="noStrike" cap="none" dirty="0" err="1">
+                <a:solidFill>
+                  <a:schemeClr val="dk1"/>
+                </a:solidFill>
+                <a:latin typeface="Rubik"/>
+                <a:ea typeface="Rubik"/>
+                <a:cs typeface="Rubik"/>
+                <a:sym typeface="Rubik"/>
+              </a:rPr>
+              <a:t>استثمارية</a:t>
+            </a:r>
+            <a:r>
+              <a:rPr lang="en-US" sz="1150" b="0" i="0" u="none" strike="noStrike" cap="none" dirty="0">
                 <a:solidFill>
                   <a:schemeClr val="dk1"/>
                 </a:solidFill>
@@ -25647,52 +25875,16 @@
               <a:t> </a:t>
             </a:r>
             <a:r>
-              <a:rPr lang="en-US" sz="1300" b="0" i="0" u="none" strike="noStrike" cap="none" dirty="0" err="1">
-                <a:solidFill>
-                  <a:schemeClr val="dk1"/>
-                </a:solidFill>
-                <a:latin typeface="Rubik"/>
-                <a:ea typeface="Rubik"/>
-                <a:cs typeface="Rubik"/>
-                <a:sym typeface="Rubik"/>
-              </a:rPr>
-              <a:t>لا</a:t>
-            </a:r>
-            <a:r>
-              <a:rPr lang="en-US" sz="1300" b="0" i="0" u="none" strike="noStrike" cap="none" dirty="0">
-                <a:solidFill>
-                  <a:schemeClr val="dk1"/>
-                </a:solidFill>
-                <a:latin typeface="Rubik"/>
-                <a:ea typeface="Rubik"/>
-                <a:cs typeface="Rubik"/>
-                <a:sym typeface="Rubik"/>
-              </a:rPr>
-              <a:t> </a:t>
-            </a:r>
-            <a:r>
-              <a:rPr lang="en-US" sz="1300" b="0" i="0" u="none" strike="noStrike" cap="none" dirty="0" err="1">
-                <a:solidFill>
-                  <a:schemeClr val="dk1"/>
-                </a:solidFill>
-                <a:latin typeface="Rubik"/>
-                <a:ea typeface="Rubik"/>
-                <a:cs typeface="Rubik"/>
-                <a:sym typeface="Rubik"/>
-              </a:rPr>
-              <a:t>تُضاهى</a:t>
-            </a:r>
-            <a:r>
-              <a:rPr lang="en-US" sz="1300" b="0" i="0" u="none" strike="noStrike" cap="none" dirty="0">
-                <a:solidFill>
-                  <a:schemeClr val="dk1"/>
-                </a:solidFill>
-                <a:latin typeface="Rubik"/>
-                <a:ea typeface="Rubik"/>
-                <a:cs typeface="Rubik"/>
-                <a:sym typeface="Rubik"/>
-              </a:rPr>
-              <a:t> 💰</a:t>
+              <a:rPr lang="en-US" sz="1150" b="0" i="0" u="none" strike="noStrike" cap="none" dirty="0" err="1">
+                <a:solidFill>
+                  <a:schemeClr val="dk1"/>
+                </a:solidFill>
+                <a:latin typeface="Rubik"/>
+                <a:ea typeface="Rubik"/>
+                <a:cs typeface="Rubik"/>
+                <a:sym typeface="Rubik"/>
+              </a:rPr>
+              <a:t>متنوعة</a:t>
             </a:r>
             <a:endParaRPr sz="1300" b="0" i="0" u="none" strike="noStrike" cap="none" dirty="0">
               <a:solidFill>
@@ -25723,16 +25915,244 @@
               <a:buNone/>
             </a:pPr>
             <a:r>
-              <a:rPr lang="en-US" sz="1300" b="0" i="0" u="none" strike="noStrike" cap="none" dirty="0" err="1">
-                <a:solidFill>
-                  <a:schemeClr val="dk1"/>
-                </a:solidFill>
-                <a:latin typeface="Rubik"/>
-                <a:ea typeface="Rubik"/>
-                <a:cs typeface="Rubik"/>
-                <a:sym typeface="Rubik"/>
-              </a:rPr>
-              <a:t>بلغت القيمة السوقية لأسواق الأسهم الأمريكية 68.9 تريليون دولار في العام الماضي، أي ما يعادل 4.4 أضعاف حجم السوق الصينية، ثاني أكبر سوق أسهم في العالم.</a:t>
+              <a:rPr lang="en-US" sz="1150" b="0" i="0" u="none" strike="noStrike" cap="none" dirty="0" err="1">
+                <a:solidFill>
+                  <a:schemeClr val="dk1"/>
+                </a:solidFill>
+                <a:latin typeface="Rubik"/>
+                <a:ea typeface="Rubik"/>
+                <a:cs typeface="Rubik"/>
+                <a:sym typeface="Rubik"/>
+              </a:rPr>
+              <a:t>أكثر من 5,500 شركة مدرجة في بورصتي نيويورك (NYSE) وناسداك (NASDAQ)، ما يمنحك خيارات واسعة بين القطاعات والشركات.</a:t>
+            </a:r>
+            <a:endParaRPr sz="1300" b="0" i="1" u="none" strike="noStrike" cap="none" dirty="0">
+              <a:solidFill>
+                <a:schemeClr val="dk1"/>
+              </a:solidFill>
+              <a:latin typeface="Rubik"/>
+              <a:ea typeface="Rubik"/>
+              <a:cs typeface="Rubik"/>
+              <a:sym typeface="Rubik"/>
+            </a:endParaRPr>
+          </a:p>
+          <a:p>
+            <a:pPr marL="0" marR="0" lvl="0" indent="0" algn="r" rtl="1">
+              <a:lnSpc>
+                <a:spcPct val="115000"/>
+              </a:lnSpc>
+              <a:spcBef>
+                <a:spcPts val="0"/>
+              </a:spcBef>
+              <a:spcAft>
+                <a:spcPts val="0"/>
+              </a:spcAft>
+              <a:buClr>
+                <a:schemeClr val="dk1"/>
+              </a:buClr>
+              <a:buSzPts val="1100"/>
+              <a:buFont typeface="Arial"/>
+              <a:buNone/>
+            </a:pPr>
+            <a:endParaRPr sz="1300" b="0" i="1" u="none" strike="noStrike" cap="none" dirty="0">
+              <a:solidFill>
+                <a:schemeClr val="dk1"/>
+              </a:solidFill>
+              <a:latin typeface="Rubik"/>
+              <a:ea typeface="Rubik"/>
+              <a:cs typeface="Rubik"/>
+              <a:sym typeface="Rubik"/>
+            </a:endParaRPr>
+          </a:p>
+          <a:p>
+            <a:pPr marL="0" marR="0" lvl="0" indent="0" algn="r" rtl="1">
+              <a:lnSpc>
+                <a:spcPct val="115000"/>
+              </a:lnSpc>
+              <a:spcBef>
+                <a:spcPts val="0"/>
+              </a:spcBef>
+              <a:spcAft>
+                <a:spcPts val="0"/>
+              </a:spcAft>
+              <a:buClr>
+                <a:schemeClr val="dk1"/>
+              </a:buClr>
+              <a:buSzPts val="974"/>
+              <a:buFont typeface="Arial"/>
+              <a:buNone/>
+            </a:pPr>
+            <a:r>
+              <a:rPr lang="en-US" sz="1150" b="0" i="0" u="none" strike="noStrike" cap="none" dirty="0" err="1">
+                <a:solidFill>
+                  <a:schemeClr val="dk1"/>
+                </a:solidFill>
+                <a:latin typeface="Rubik Medium"/>
+                <a:ea typeface="Rubik Medium"/>
+                <a:cs typeface="Rubik Medium"/>
+                <a:sym typeface="Rubik Medium"/>
+              </a:rPr>
+              <a:t>البوست</a:t>
+            </a:r>
+            <a:r>
+              <a:rPr lang="en-US" sz="1150" b="0" i="0" u="none" strike="noStrike" cap="none" dirty="0">
+                <a:solidFill>
+                  <a:schemeClr val="dk1"/>
+                </a:solidFill>
+                <a:latin typeface="Rubik Medium"/>
+                <a:ea typeface="Rubik Medium"/>
+                <a:cs typeface="Rubik Medium"/>
+                <a:sym typeface="Rubik Medium"/>
+              </a:rPr>
+              <a:t> </a:t>
+            </a:r>
+            <a:r>
+              <a:rPr lang="en-US" sz="1150" b="0" i="0" u="none" strike="noStrike" cap="none" dirty="0" err="1">
+                <a:solidFill>
+                  <a:schemeClr val="dk1"/>
+                </a:solidFill>
+                <a:latin typeface="Rubik Medium"/>
+                <a:ea typeface="Rubik Medium"/>
+                <a:cs typeface="Rubik Medium"/>
+                <a:sym typeface="Rubik Medium"/>
+              </a:rPr>
+              <a:t>الخامس</a:t>
+            </a:r>
+            <a:r>
+              <a:rPr lang="en-US" sz="1150" b="0" i="0" u="none" strike="noStrike" cap="none" dirty="0">
+                <a:solidFill>
+                  <a:schemeClr val="dk1"/>
+                </a:solidFill>
+                <a:latin typeface="Rubik Medium"/>
+                <a:ea typeface="Rubik Medium"/>
+                <a:cs typeface="Rubik Medium"/>
+                <a:sym typeface="Rubik Medium"/>
+              </a:rPr>
+              <a:t>: </a:t>
+            </a:r>
+            <a:endParaRPr sz="1300" b="0" i="1" u="none" strike="noStrike" cap="none" dirty="0">
+              <a:solidFill>
+                <a:schemeClr val="dk1"/>
+              </a:solidFill>
+              <a:latin typeface="Rubik"/>
+              <a:ea typeface="Rubik"/>
+              <a:cs typeface="Rubik"/>
+              <a:sym typeface="Rubik"/>
+            </a:endParaRPr>
+          </a:p>
+          <a:p>
+            <a:pPr marL="0" marR="0" lvl="0" indent="0" algn="r" rtl="1">
+              <a:lnSpc>
+                <a:spcPct val="115000"/>
+              </a:lnSpc>
+              <a:spcBef>
+                <a:spcPts val="0"/>
+              </a:spcBef>
+              <a:spcAft>
+                <a:spcPts val="0"/>
+              </a:spcAft>
+              <a:buClr>
+                <a:schemeClr val="dk1"/>
+              </a:buClr>
+              <a:buSzPts val="1100"/>
+              <a:buFont typeface="Arial"/>
+              <a:buNone/>
+            </a:pPr>
+            <a:r>
+              <a:rPr lang="en-US" sz="1150" b="0" i="0" u="none" strike="noStrike" cap="none" dirty="0" err="1">
+                <a:solidFill>
+                  <a:schemeClr val="dk1"/>
+                </a:solidFill>
+                <a:latin typeface="Rubik"/>
+                <a:ea typeface="Rubik"/>
+                <a:cs typeface="Rubik"/>
+                <a:sym typeface="Rubik"/>
+              </a:rPr>
+              <a:t>البداية</a:t>
+            </a:r>
+            <a:r>
+              <a:rPr lang="en-US" sz="1150" b="0" i="0" u="none" strike="noStrike" cap="none" dirty="0">
+                <a:solidFill>
+                  <a:schemeClr val="dk1"/>
+                </a:solidFill>
+                <a:latin typeface="Rubik"/>
+                <a:ea typeface="Rubik"/>
+                <a:cs typeface="Rubik"/>
+                <a:sym typeface="Rubik"/>
+              </a:rPr>
+              <a:t> </a:t>
+            </a:r>
+            <a:r>
+              <a:rPr lang="en-US" sz="1150" b="0" i="0" u="none" strike="noStrike" cap="none" dirty="0" err="1">
+                <a:solidFill>
+                  <a:schemeClr val="dk1"/>
+                </a:solidFill>
+                <a:latin typeface="Rubik"/>
+                <a:ea typeface="Rubik"/>
+                <a:cs typeface="Rubik"/>
+                <a:sym typeface="Rubik"/>
+              </a:rPr>
+              <a:t>أسهل</a:t>
+            </a:r>
+            <a:r>
+              <a:rPr lang="en-US" sz="1150" b="0" i="0" u="none" strike="noStrike" cap="none" dirty="0">
+                <a:solidFill>
+                  <a:schemeClr val="dk1"/>
+                </a:solidFill>
+                <a:latin typeface="Rubik"/>
+                <a:ea typeface="Rubik"/>
+                <a:cs typeface="Rubik"/>
+                <a:sym typeface="Rubik"/>
+              </a:rPr>
+              <a:t> </a:t>
+            </a:r>
+            <a:r>
+              <a:rPr lang="en-US" sz="1150" b="0" i="0" u="none" strike="noStrike" cap="none" dirty="0" err="1">
+                <a:solidFill>
+                  <a:schemeClr val="dk1"/>
+                </a:solidFill>
+                <a:latin typeface="Rubik"/>
+                <a:ea typeface="Rubik"/>
+                <a:cs typeface="Rubik"/>
+                <a:sym typeface="Rubik"/>
+              </a:rPr>
+              <a:t>ممّا</a:t>
+            </a:r>
+            <a:r>
+              <a:rPr lang="en-US" sz="1150" b="0" i="0" u="none" strike="noStrike" cap="none" dirty="0">
+                <a:solidFill>
+                  <a:schemeClr val="dk1"/>
+                </a:solidFill>
+                <a:latin typeface="Rubik"/>
+                <a:ea typeface="Rubik"/>
+                <a:cs typeface="Rubik"/>
+                <a:sym typeface="Rubik"/>
+              </a:rPr>
+              <a:t> </a:t>
+            </a:r>
+            <a:r>
+              <a:rPr lang="en-US" sz="1150" b="0" i="0" u="none" strike="noStrike" cap="none" dirty="0" err="1">
+                <a:solidFill>
+                  <a:schemeClr val="dk1"/>
+                </a:solidFill>
+                <a:latin typeface="Rubik"/>
+                <a:ea typeface="Rubik"/>
+                <a:cs typeface="Rubik"/>
+                <a:sym typeface="Rubik"/>
+              </a:rPr>
+              <a:t>تتخيل</a:t>
+            </a:r>
+            <a:r>
+              <a:rPr lang="en-US" sz="1150" b="0" i="0" u="none" strike="noStrike" cap="none" dirty="0">
+                <a:solidFill>
+                  <a:schemeClr val="dk1"/>
+                </a:solidFill>
+                <a:latin typeface="Rubik"/>
+                <a:ea typeface="Rubik"/>
+                <a:cs typeface="Rubik"/>
+                <a:sym typeface="Rubik"/>
+              </a:rPr>
+              <a:t>! 💡</a:t>
             </a:r>
             <a:endParaRPr sz="1300" b="0" i="0" u="none" strike="noStrike" cap="none" dirty="0">
               <a:solidFill>
@@ -25763,16 +26183,376 @@
               <a:buNone/>
             </a:pPr>
             <a:r>
-              <a:rPr lang="en-US" sz="1300" b="0" i="1" u="none" strike="noStrike" cap="none" dirty="0" err="1">
-                <a:solidFill>
-                  <a:schemeClr val="dk1"/>
-                </a:solidFill>
-                <a:latin typeface="Rubik"/>
-                <a:ea typeface="Rubik"/>
-                <a:cs typeface="Rubik"/>
-                <a:sym typeface="Rubik"/>
-              </a:rPr>
-              <a:t>المصدر: SIFMA - Capital Markets Fact Book 2026</a:t>
+              <a:rPr lang="en-US" sz="1150" b="0" i="0" u="none" strike="noStrike" cap="none" dirty="0" err="1">
+                <a:solidFill>
+                  <a:schemeClr val="dk1"/>
+                </a:solidFill>
+                <a:latin typeface="Rubik"/>
+                <a:ea typeface="Rubik"/>
+                <a:cs typeface="Rubik"/>
+                <a:sym typeface="Rubik"/>
+              </a:rPr>
+              <a:t>استكشف</a:t>
+            </a:r>
+            <a:r>
+              <a:rPr lang="en-US" sz="1150" b="0" i="0" u="none" strike="noStrike" cap="none" dirty="0">
+                <a:solidFill>
+                  <a:schemeClr val="dk1"/>
+                </a:solidFill>
+                <a:latin typeface="Rubik"/>
+                <a:ea typeface="Rubik"/>
+                <a:cs typeface="Rubik"/>
+                <a:sym typeface="Rubik"/>
+              </a:rPr>
+              <a:t> </a:t>
+            </a:r>
+            <a:r>
+              <a:rPr lang="en-US" sz="1150" b="0" i="0" u="none" strike="noStrike" cap="none" dirty="0" err="1">
+                <a:solidFill>
+                  <a:schemeClr val="dk1"/>
+                </a:solidFill>
+                <a:latin typeface="Rubik"/>
+                <a:ea typeface="Rubik"/>
+                <a:cs typeface="Rubik"/>
+                <a:sym typeface="Rubik"/>
+              </a:rPr>
+              <a:t>مجموعة</a:t>
+            </a:r>
+            <a:r>
+              <a:rPr lang="en-US" sz="1150" b="0" i="0" u="none" strike="noStrike" cap="none" dirty="0">
+                <a:solidFill>
+                  <a:schemeClr val="dk1"/>
+                </a:solidFill>
+                <a:latin typeface="Rubik"/>
+                <a:ea typeface="Rubik"/>
+                <a:cs typeface="Rubik"/>
+                <a:sym typeface="Rubik"/>
+              </a:rPr>
+              <a:t> </a:t>
+            </a:r>
+            <a:r>
+              <a:rPr lang="en-US" sz="1150" b="0" i="0" u="none" strike="noStrike" cap="none" dirty="0" err="1">
+                <a:solidFill>
+                  <a:schemeClr val="dk1"/>
+                </a:solidFill>
+                <a:latin typeface="Rubik"/>
+                <a:ea typeface="Rubik"/>
+                <a:cs typeface="Rubik"/>
+                <a:sym typeface="Rubik"/>
+              </a:rPr>
+              <a:t>مختارة</a:t>
+            </a:r>
+            <a:r>
+              <a:rPr lang="en-US" sz="1150" b="0" i="0" u="none" strike="noStrike" cap="none" dirty="0">
+                <a:solidFill>
+                  <a:schemeClr val="dk1"/>
+                </a:solidFill>
+                <a:latin typeface="Rubik"/>
+                <a:ea typeface="Rubik"/>
+                <a:cs typeface="Rubik"/>
+                <a:sym typeface="Rubik"/>
+              </a:rPr>
+              <a:t> </a:t>
+            </a:r>
+            <a:r>
+              <a:rPr lang="en-US" sz="1150" b="0" i="0" u="none" strike="noStrike" cap="none" dirty="0" err="1">
+                <a:solidFill>
+                  <a:schemeClr val="dk1"/>
+                </a:solidFill>
+                <a:latin typeface="Rubik"/>
+                <a:ea typeface="Rubik"/>
+                <a:cs typeface="Rubik"/>
+                <a:sym typeface="Rubik"/>
+              </a:rPr>
+              <a:t>من</a:t>
+            </a:r>
+            <a:r>
+              <a:rPr lang="en-US" sz="1150" b="0" i="0" u="none" strike="noStrike" cap="none" dirty="0">
+                <a:solidFill>
+                  <a:schemeClr val="dk1"/>
+                </a:solidFill>
+                <a:latin typeface="Rubik"/>
+                <a:ea typeface="Rubik"/>
+                <a:cs typeface="Rubik"/>
+                <a:sym typeface="Rubik"/>
+              </a:rPr>
+              <a:t> </a:t>
+            </a:r>
+            <a:r>
+              <a:rPr lang="en-US" sz="1150" b="0" i="0" u="none" strike="noStrike" cap="none" dirty="0" err="1">
+                <a:solidFill>
+                  <a:schemeClr val="dk1"/>
+                </a:solidFill>
+                <a:latin typeface="Rubik"/>
+                <a:ea typeface="Rubik"/>
+                <a:cs typeface="Rubik"/>
+                <a:sym typeface="Rubik"/>
+              </a:rPr>
+              <a:t>الأسهم</a:t>
+            </a:r>
+            <a:r>
+              <a:rPr lang="en-US" sz="1150" b="0" i="0" u="none" strike="noStrike" cap="none" dirty="0">
+                <a:solidFill>
+                  <a:schemeClr val="dk1"/>
+                </a:solidFill>
+                <a:latin typeface="Rubik"/>
+                <a:ea typeface="Rubik"/>
+                <a:cs typeface="Rubik"/>
+                <a:sym typeface="Rubik"/>
+              </a:rPr>
+              <a:t> </a:t>
+            </a:r>
+            <a:r>
+              <a:rPr lang="en-US" sz="1150" b="0" i="0" u="none" strike="noStrike" cap="none" dirty="0" err="1">
+                <a:solidFill>
+                  <a:schemeClr val="dk1"/>
+                </a:solidFill>
+                <a:latin typeface="Rubik"/>
+                <a:ea typeface="Rubik"/>
+                <a:cs typeface="Rubik"/>
+                <a:sym typeface="Rubik"/>
+              </a:rPr>
+              <a:t>الأمريكية</a:t>
+            </a:r>
+            <a:r>
+              <a:rPr lang="en-US" sz="1150" b="0" i="0" u="none" strike="noStrike" cap="none" dirty="0">
+                <a:solidFill>
+                  <a:schemeClr val="dk1"/>
+                </a:solidFill>
+                <a:latin typeface="Rubik"/>
+                <a:ea typeface="Rubik"/>
+                <a:cs typeface="Rubik"/>
+                <a:sym typeface="Rubik"/>
+              </a:rPr>
+              <a:t> </a:t>
+            </a:r>
+            <a:r>
+              <a:rPr lang="en-US" sz="1150" b="0" i="0" u="none" strike="noStrike" cap="none" dirty="0" err="1">
+                <a:solidFill>
+                  <a:schemeClr val="dk1"/>
+                </a:solidFill>
+                <a:latin typeface="Rubik"/>
+                <a:ea typeface="Rubik"/>
+                <a:cs typeface="Rubik"/>
+                <a:sym typeface="Rubik"/>
+              </a:rPr>
+              <a:t>عبر</a:t>
+            </a:r>
+            <a:r>
+              <a:rPr lang="en-US" sz="1150" b="0" i="0" u="none" strike="noStrike" cap="none" dirty="0">
+                <a:solidFill>
+                  <a:schemeClr val="dk1"/>
+                </a:solidFill>
+                <a:latin typeface="Rubik"/>
+                <a:ea typeface="Rubik"/>
+                <a:cs typeface="Rubik"/>
+                <a:sym typeface="Rubik"/>
+              </a:rPr>
+              <a:t> </a:t>
+            </a:r>
+            <a:r>
+              <a:rPr lang="en-US" sz="1150" b="0" i="0" u="none" strike="noStrike" cap="none" dirty="0" err="1">
+                <a:solidFill>
+                  <a:schemeClr val="dk1"/>
+                </a:solidFill>
+                <a:latin typeface="Rubik"/>
+                <a:ea typeface="Rubik"/>
+                <a:cs typeface="Rubik"/>
+                <a:sym typeface="Rubik"/>
+              </a:rPr>
+              <a:t>تطبيق</a:t>
+            </a:r>
+            <a:r>
+              <a:rPr lang="en-US" sz="1150" b="0" i="0" u="none" strike="noStrike" cap="none" dirty="0">
+                <a:solidFill>
+                  <a:schemeClr val="dk1"/>
+                </a:solidFill>
+                <a:latin typeface="Rubik"/>
+                <a:ea typeface="Rubik"/>
+                <a:cs typeface="Rubik"/>
+                <a:sym typeface="Rubik"/>
+              </a:rPr>
+              <a:t> </a:t>
+            </a:r>
+            <a:r>
+              <a:rPr lang="en-US" sz="1150" b="0" i="0" u="none" strike="noStrike" cap="none" dirty="0" err="1">
+                <a:solidFill>
+                  <a:schemeClr val="dk1"/>
+                </a:solidFill>
+                <a:latin typeface="Rubik"/>
+                <a:ea typeface="Rubik"/>
+                <a:cs typeface="Rubik"/>
+                <a:sym typeface="Rubik"/>
+              </a:rPr>
+              <a:t>eMYAA</a:t>
+            </a:r>
+            <a:r>
+              <a:rPr lang="en-US" sz="1150" b="0" i="0" u="none" strike="noStrike" cap="none" dirty="0">
+                <a:solidFill>
+                  <a:schemeClr val="dk1"/>
+                </a:solidFill>
+                <a:latin typeface="Rubik"/>
+                <a:ea typeface="Rubik"/>
+                <a:cs typeface="Rubik"/>
+                <a:sym typeface="Rubik"/>
+              </a:rPr>
+              <a:t>، </a:t>
+            </a:r>
+            <a:r>
+              <a:rPr lang="en-US" sz="1150" b="0" i="0" u="none" strike="noStrike" cap="none" dirty="0" err="1">
+                <a:solidFill>
+                  <a:schemeClr val="dk1"/>
+                </a:solidFill>
+                <a:latin typeface="Rubik"/>
+                <a:ea typeface="Rubik"/>
+                <a:cs typeface="Rubik"/>
+                <a:sym typeface="Rubik"/>
+              </a:rPr>
+              <a:t>بحد</a:t>
+            </a:r>
+            <a:r>
+              <a:rPr lang="en-US" sz="1150" b="0" i="0" u="none" strike="noStrike" cap="none" dirty="0">
+                <a:solidFill>
+                  <a:schemeClr val="dk1"/>
+                </a:solidFill>
+                <a:latin typeface="Rubik"/>
+                <a:ea typeface="Rubik"/>
+                <a:cs typeface="Rubik"/>
+                <a:sym typeface="Rubik"/>
+              </a:rPr>
+              <a:t> </a:t>
+            </a:r>
+            <a:r>
+              <a:rPr lang="en-US" sz="1150" b="0" i="0" u="none" strike="noStrike" cap="none" dirty="0" err="1">
+                <a:solidFill>
+                  <a:schemeClr val="dk1"/>
+                </a:solidFill>
+                <a:latin typeface="Rubik"/>
+                <a:ea typeface="Rubik"/>
+                <a:cs typeface="Rubik"/>
+                <a:sym typeface="Rubik"/>
+              </a:rPr>
+              <a:t>أدنى</a:t>
+            </a:r>
+            <a:r>
+              <a:rPr lang="en-US" sz="1150" b="0" i="0" u="none" strike="noStrike" cap="none" dirty="0">
+                <a:solidFill>
+                  <a:schemeClr val="dk1"/>
+                </a:solidFill>
+                <a:latin typeface="Rubik"/>
+                <a:ea typeface="Rubik"/>
+                <a:cs typeface="Rubik"/>
+                <a:sym typeface="Rubik"/>
+              </a:rPr>
+              <a:t> </a:t>
+            </a:r>
+            <a:r>
+              <a:rPr lang="en-US" sz="1150" b="0" i="0" u="none" strike="noStrike" cap="none" dirty="0" err="1">
+                <a:solidFill>
+                  <a:schemeClr val="dk1"/>
+                </a:solidFill>
+                <a:latin typeface="Rubik"/>
+                <a:ea typeface="Rubik"/>
+                <a:cs typeface="Rubik"/>
+                <a:sym typeface="Rubik"/>
+              </a:rPr>
+              <a:t>للإيداع</a:t>
+            </a:r>
+            <a:r>
+              <a:rPr lang="en-US" sz="1150" b="0" i="0" u="none" strike="noStrike" cap="none" dirty="0">
+                <a:solidFill>
+                  <a:schemeClr val="dk1"/>
+                </a:solidFill>
+                <a:latin typeface="Rubik"/>
+                <a:ea typeface="Rubik"/>
+                <a:cs typeface="Rubik"/>
+                <a:sym typeface="Rubik"/>
+              </a:rPr>
+              <a:t> </a:t>
+            </a:r>
+            <a:r>
+              <a:rPr lang="en-US" sz="1150" b="0" i="0" u="none" strike="noStrike" cap="none" dirty="0" err="1">
+                <a:solidFill>
+                  <a:schemeClr val="dk1"/>
+                </a:solidFill>
+                <a:latin typeface="Rubik"/>
+                <a:ea typeface="Rubik"/>
+                <a:cs typeface="Rubik"/>
+                <a:sym typeface="Rubik"/>
+              </a:rPr>
+              <a:t>يبدأ</a:t>
+            </a:r>
+            <a:r>
+              <a:rPr lang="en-US" sz="1150" b="0" i="0" u="none" strike="noStrike" cap="none" dirty="0">
+                <a:solidFill>
+                  <a:schemeClr val="dk1"/>
+                </a:solidFill>
+                <a:latin typeface="Rubik"/>
+                <a:ea typeface="Rubik"/>
+                <a:cs typeface="Rubik"/>
+                <a:sym typeface="Rubik"/>
+              </a:rPr>
+              <a:t> </a:t>
+            </a:r>
+            <a:r>
+              <a:rPr lang="en-US" sz="1150" b="0" i="0" u="none" strike="noStrike" cap="none" dirty="0" err="1">
+                <a:solidFill>
+                  <a:schemeClr val="dk1"/>
+                </a:solidFill>
+                <a:latin typeface="Rubik"/>
+                <a:ea typeface="Rubik"/>
+                <a:cs typeface="Rubik"/>
+                <a:sym typeface="Rubik"/>
+              </a:rPr>
+              <a:t>من</a:t>
+            </a:r>
+            <a:r>
+              <a:rPr lang="en-US" sz="1150" b="0" i="0" u="none" strike="noStrike" cap="none" dirty="0">
+                <a:solidFill>
+                  <a:schemeClr val="dk1"/>
+                </a:solidFill>
+                <a:latin typeface="Rubik"/>
+                <a:ea typeface="Rubik"/>
+                <a:cs typeface="Rubik"/>
+                <a:sym typeface="Rubik"/>
+              </a:rPr>
+              <a:t> 50 </a:t>
+            </a:r>
+            <a:r>
+              <a:rPr lang="en-US" sz="1150" b="0" i="0" u="none" strike="noStrike" cap="none" dirty="0" err="1">
+                <a:solidFill>
+                  <a:schemeClr val="dk1"/>
+                </a:solidFill>
+                <a:latin typeface="Rubik"/>
+                <a:ea typeface="Rubik"/>
+                <a:cs typeface="Rubik"/>
+                <a:sym typeface="Rubik"/>
+              </a:rPr>
+              <a:t>دولاراً</a:t>
+            </a:r>
+            <a:r>
+              <a:rPr lang="en-US" sz="1150" b="0" i="0" u="none" strike="noStrike" cap="none" dirty="0">
+                <a:solidFill>
+                  <a:schemeClr val="dk1"/>
+                </a:solidFill>
+                <a:latin typeface="Rubik"/>
+                <a:ea typeface="Rubik"/>
+                <a:cs typeface="Rubik"/>
+                <a:sym typeface="Rubik"/>
+              </a:rPr>
+              <a:t> </a:t>
+            </a:r>
+            <a:r>
+              <a:rPr lang="en-US" sz="1150" b="0" i="0" u="none" strike="noStrike" cap="none" dirty="0" err="1">
+                <a:solidFill>
+                  <a:schemeClr val="dk1"/>
+                </a:solidFill>
+                <a:latin typeface="Rubik"/>
+                <a:ea typeface="Rubik"/>
+                <a:cs typeface="Rubik"/>
+                <a:sym typeface="Rubik"/>
+              </a:rPr>
+              <a:t>فقط</a:t>
             </a:r>
             <a:endParaRPr sz="1300" b="0" i="0" u="none" strike="noStrike" cap="none" dirty="0">
               <a:solidFill>
@@ -25831,7 +26611,7 @@
               <a:buNone/>
             </a:pPr>
             <a:r>
-              <a:rPr lang="en-US" sz="1300" b="0" i="0" u="none" strike="noStrike" cap="none" dirty="0" err="1">
+              <a:rPr lang="en-US" sz="1150" b="0" i="0" u="none" strike="noStrike" cap="none" dirty="0" err="1">
                 <a:solidFill>
                   <a:schemeClr val="dk1"/>
                 </a:solidFill>
@@ -25840,555 +26620,7 @@
                 <a:cs typeface="Rubik Medium"/>
                 <a:sym typeface="Rubik Medium"/>
               </a:rPr>
-              <a:t>البوست</a:t>
-            </a:r>
-            <a:r>
-              <a:rPr lang="en-US" sz="1300" b="0" i="0" u="none" strike="noStrike" cap="none" dirty="0">
-                <a:solidFill>
-                  <a:schemeClr val="dk1"/>
-                </a:solidFill>
-                <a:latin typeface="Rubik Medium"/>
-                <a:ea typeface="Rubik Medium"/>
-                <a:cs typeface="Rubik Medium"/>
-                <a:sym typeface="Rubik Medium"/>
-              </a:rPr>
-              <a:t> </a:t>
-            </a:r>
-            <a:r>
-              <a:rPr lang="en-US" sz="1300" b="0" i="0" u="none" strike="noStrike" cap="none" dirty="0" err="1">
-                <a:solidFill>
-                  <a:schemeClr val="dk1"/>
-                </a:solidFill>
-                <a:latin typeface="Rubik Medium"/>
-                <a:ea typeface="Rubik Medium"/>
-                <a:cs typeface="Rubik Medium"/>
-                <a:sym typeface="Rubik Medium"/>
-              </a:rPr>
-              <a:t>الرابع</a:t>
-            </a:r>
-            <a:r>
-              <a:rPr lang="en-US" sz="1300" b="0" i="0" u="none" strike="noStrike" cap="none" dirty="0">
-                <a:solidFill>
-                  <a:schemeClr val="dk1"/>
-                </a:solidFill>
-                <a:latin typeface="Rubik Medium"/>
-                <a:ea typeface="Rubik Medium"/>
-                <a:cs typeface="Rubik Medium"/>
-                <a:sym typeface="Rubik Medium"/>
-              </a:rPr>
-              <a:t>: </a:t>
-            </a:r>
-            <a:endParaRPr sz="1300" b="0" i="0" u="none" strike="noStrike" cap="none" dirty="0">
-              <a:solidFill>
-                <a:schemeClr val="dk1"/>
-              </a:solidFill>
-              <a:latin typeface="Montserrat SemiBold"/>
-              <a:ea typeface="Montserrat SemiBold"/>
-              <a:cs typeface="Montserrat SemiBold"/>
-              <a:sym typeface="Montserrat SemiBold"/>
-            </a:endParaRPr>
-          </a:p>
-          <a:p>
-            <a:pPr marL="0" marR="0" lvl="0" indent="0" algn="r" rtl="1">
-              <a:lnSpc>
-                <a:spcPct val="115000"/>
-              </a:lnSpc>
-              <a:spcBef>
-                <a:spcPts val="0"/>
-              </a:spcBef>
-              <a:spcAft>
-                <a:spcPts val="0"/>
-              </a:spcAft>
-              <a:buClr>
-                <a:schemeClr val="dk1"/>
-              </a:buClr>
-              <a:buSzPts val="1100"/>
-              <a:buFont typeface="Arial"/>
-              <a:buNone/>
-            </a:pPr>
-            <a:r>
-              <a:rPr lang="en-US" sz="1300" b="0" i="0" u="none" strike="noStrike" cap="none" dirty="0" err="1">
-                <a:solidFill>
-                  <a:schemeClr val="dk1"/>
-                </a:solidFill>
-                <a:latin typeface="Rubik"/>
-                <a:ea typeface="Rubik"/>
-                <a:cs typeface="Rubik"/>
-                <a:sym typeface="Rubik"/>
-              </a:rPr>
-              <a:t>خيارات</a:t>
-            </a:r>
-            <a:r>
-              <a:rPr lang="en-US" sz="1300" b="0" i="0" u="none" strike="noStrike" cap="none" dirty="0">
-                <a:solidFill>
-                  <a:schemeClr val="dk1"/>
-                </a:solidFill>
-                <a:latin typeface="Rubik"/>
-                <a:ea typeface="Rubik"/>
-                <a:cs typeface="Rubik"/>
-                <a:sym typeface="Rubik"/>
-              </a:rPr>
-              <a:t> </a:t>
-            </a:r>
-            <a:r>
-              <a:rPr lang="en-US" sz="1300" b="0" i="0" u="none" strike="noStrike" cap="none" dirty="0" err="1">
-                <a:solidFill>
-                  <a:schemeClr val="dk1"/>
-                </a:solidFill>
-                <a:latin typeface="Rubik"/>
-                <a:ea typeface="Rubik"/>
-                <a:cs typeface="Rubik"/>
-                <a:sym typeface="Rubik"/>
-              </a:rPr>
-              <a:t>استثمارية</a:t>
-            </a:r>
-            <a:r>
-              <a:rPr lang="en-US" sz="1300" b="0" i="0" u="none" strike="noStrike" cap="none" dirty="0">
-                <a:solidFill>
-                  <a:schemeClr val="dk1"/>
-                </a:solidFill>
-                <a:latin typeface="Rubik"/>
-                <a:ea typeface="Rubik"/>
-                <a:cs typeface="Rubik"/>
-                <a:sym typeface="Rubik"/>
-              </a:rPr>
-              <a:t> </a:t>
-            </a:r>
-            <a:r>
-              <a:rPr lang="en-US" sz="1300" b="0" i="0" u="none" strike="noStrike" cap="none" dirty="0" err="1">
-                <a:solidFill>
-                  <a:schemeClr val="dk1"/>
-                </a:solidFill>
-                <a:latin typeface="Rubik"/>
-                <a:ea typeface="Rubik"/>
-                <a:cs typeface="Rubik"/>
-                <a:sym typeface="Rubik"/>
-              </a:rPr>
-              <a:t>متنوعة</a:t>
-            </a:r>
-            <a:endParaRPr sz="1300" b="0" i="0" u="none" strike="noStrike" cap="none" dirty="0">
-              <a:solidFill>
-                <a:schemeClr val="dk1"/>
-              </a:solidFill>
-              <a:latin typeface="Rubik"/>
-              <a:ea typeface="Rubik"/>
-              <a:cs typeface="Rubik"/>
-              <a:sym typeface="Rubik"/>
-            </a:endParaRPr>
-          </a:p>
-          <a:p>
-            <a:pPr marL="0" marR="0" lvl="0" indent="0" algn="r" rtl="1">
-              <a:lnSpc>
-                <a:spcPct val="115000"/>
-              </a:lnSpc>
-              <a:spcBef>
-                <a:spcPts val="0"/>
-              </a:spcBef>
-              <a:spcAft>
-                <a:spcPts val="0"/>
-              </a:spcAft>
-              <a:buClr>
-                <a:schemeClr val="dk1"/>
-              </a:buClr>
-              <a:buSzPts val="1100"/>
-              <a:buFont typeface="Arial"/>
-              <a:buNone/>
-            </a:pPr>
-            <a:r>
-              <a:rPr lang="en-US" sz="1300" b="0" i="0" u="none" strike="noStrike" cap="none" dirty="0" err="1">
-                <a:solidFill>
-                  <a:schemeClr val="dk1"/>
-                </a:solidFill>
-                <a:latin typeface="Rubik"/>
-                <a:ea typeface="Rubik"/>
-                <a:cs typeface="Rubik"/>
-                <a:sym typeface="Rubik"/>
-              </a:rPr>
-              <a:t>أكثر</a:t>
-            </a:r>
-            <a:r>
-              <a:rPr lang="en-US" sz="1300" b="0" i="0" u="none" strike="noStrike" cap="none" dirty="0">
-                <a:solidFill>
-                  <a:schemeClr val="dk1"/>
-                </a:solidFill>
-                <a:latin typeface="Rubik"/>
-                <a:ea typeface="Rubik"/>
-                <a:cs typeface="Rubik"/>
-                <a:sym typeface="Rubik"/>
-              </a:rPr>
-              <a:t> </a:t>
-            </a:r>
-            <a:r>
-              <a:rPr lang="en-US" sz="1300" b="0" i="0" u="none" strike="noStrike" cap="none" dirty="0" err="1">
-                <a:solidFill>
-                  <a:schemeClr val="dk1"/>
-                </a:solidFill>
-                <a:latin typeface="Rubik"/>
-                <a:ea typeface="Rubik"/>
-                <a:cs typeface="Rubik"/>
-                <a:sym typeface="Rubik"/>
-              </a:rPr>
-              <a:t>من</a:t>
-            </a:r>
-            <a:r>
-              <a:rPr lang="en-US" sz="1300" b="0" i="0" u="none" strike="noStrike" cap="none" dirty="0">
-                <a:solidFill>
-                  <a:schemeClr val="dk1"/>
-                </a:solidFill>
-                <a:latin typeface="Rubik"/>
-                <a:ea typeface="Rubik"/>
-                <a:cs typeface="Rubik"/>
-                <a:sym typeface="Rubik"/>
-              </a:rPr>
-              <a:t> 5,500 </a:t>
-            </a:r>
-            <a:r>
-              <a:rPr lang="en-US" sz="1300" b="0" i="0" u="none" strike="noStrike" cap="none" dirty="0" err="1">
-                <a:solidFill>
-                  <a:schemeClr val="dk1"/>
-                </a:solidFill>
-                <a:latin typeface="Rubik"/>
-                <a:ea typeface="Rubik"/>
-                <a:cs typeface="Rubik"/>
-                <a:sym typeface="Rubik"/>
-              </a:rPr>
-              <a:t>شركة</a:t>
-            </a:r>
-            <a:r>
-              <a:rPr lang="en-US" sz="1300" b="0" i="0" u="none" strike="noStrike" cap="none" dirty="0">
-                <a:solidFill>
-                  <a:schemeClr val="dk1"/>
-                </a:solidFill>
-                <a:latin typeface="Rubik"/>
-                <a:ea typeface="Rubik"/>
-                <a:cs typeface="Rubik"/>
-                <a:sym typeface="Rubik"/>
-              </a:rPr>
-              <a:t> </a:t>
-            </a:r>
-            <a:r>
-              <a:rPr lang="en-US" sz="1300" b="0" i="0" u="none" strike="noStrike" cap="none" dirty="0" err="1">
-                <a:solidFill>
-                  <a:schemeClr val="dk1"/>
-                </a:solidFill>
-                <a:latin typeface="Rubik"/>
-                <a:ea typeface="Rubik"/>
-                <a:cs typeface="Rubik"/>
-                <a:sym typeface="Rubik"/>
-              </a:rPr>
-              <a:t>مدرجة</a:t>
-            </a:r>
-            <a:r>
-              <a:rPr lang="en-US" sz="1300" b="0" i="0" u="none" strike="noStrike" cap="none" dirty="0">
-                <a:solidFill>
-                  <a:schemeClr val="dk1"/>
-                </a:solidFill>
-                <a:latin typeface="Rubik"/>
-                <a:ea typeface="Rubik"/>
-                <a:cs typeface="Rubik"/>
-                <a:sym typeface="Rubik"/>
-              </a:rPr>
-              <a:t> </a:t>
-            </a:r>
-            <a:r>
-              <a:rPr lang="en-US" sz="1300" b="0" i="0" u="none" strike="noStrike" cap="none" dirty="0" err="1">
-                <a:solidFill>
-                  <a:schemeClr val="dk1"/>
-                </a:solidFill>
-                <a:latin typeface="Rubik"/>
-                <a:ea typeface="Rubik"/>
-                <a:cs typeface="Rubik"/>
-                <a:sym typeface="Rubik"/>
-              </a:rPr>
-              <a:t>في</a:t>
-            </a:r>
-            <a:r>
-              <a:rPr lang="en-US" sz="1300" b="0" i="0" u="none" strike="noStrike" cap="none" dirty="0">
-                <a:solidFill>
-                  <a:schemeClr val="dk1"/>
-                </a:solidFill>
-                <a:latin typeface="Rubik"/>
-                <a:ea typeface="Rubik"/>
-                <a:cs typeface="Rubik"/>
-                <a:sym typeface="Rubik"/>
-              </a:rPr>
-              <a:t> </a:t>
-            </a:r>
-            <a:r>
-              <a:rPr lang="en-US" sz="1300" b="0" i="0" u="none" strike="noStrike" cap="none" dirty="0" err="1">
-                <a:solidFill>
-                  <a:schemeClr val="dk1"/>
-                </a:solidFill>
-                <a:latin typeface="Rubik"/>
-                <a:ea typeface="Rubik"/>
-                <a:cs typeface="Rubik"/>
-                <a:sym typeface="Rubik"/>
-              </a:rPr>
-              <a:t>بورصتي</a:t>
-            </a:r>
-            <a:r>
-              <a:rPr lang="en-US" sz="1300" b="0" i="0" u="none" strike="noStrike" cap="none" dirty="0">
-                <a:solidFill>
-                  <a:schemeClr val="dk1"/>
-                </a:solidFill>
-                <a:latin typeface="Rubik"/>
-                <a:ea typeface="Rubik"/>
-                <a:cs typeface="Rubik"/>
-                <a:sym typeface="Rubik"/>
-              </a:rPr>
-              <a:t> </a:t>
-            </a:r>
-            <a:r>
-              <a:rPr lang="en-US" sz="1300" b="0" i="0" u="none" strike="noStrike" cap="none" dirty="0" err="1">
-                <a:solidFill>
-                  <a:schemeClr val="dk1"/>
-                </a:solidFill>
-                <a:latin typeface="Rubik"/>
-                <a:ea typeface="Rubik"/>
-                <a:cs typeface="Rubik"/>
-                <a:sym typeface="Rubik"/>
-              </a:rPr>
-              <a:t>نيويورك</a:t>
-            </a:r>
-            <a:r>
-              <a:rPr lang="en-US" sz="1300" b="0" i="0" u="none" strike="noStrike" cap="none" dirty="0">
-                <a:solidFill>
-                  <a:schemeClr val="dk1"/>
-                </a:solidFill>
-                <a:latin typeface="Rubik"/>
-                <a:ea typeface="Rubik"/>
-                <a:cs typeface="Rubik"/>
-                <a:sym typeface="Rubik"/>
-              </a:rPr>
-              <a:t> (NYSE) </a:t>
-            </a:r>
-            <a:r>
-              <a:rPr lang="en-US" sz="1300" b="0" i="0" u="none" strike="noStrike" cap="none" dirty="0" err="1">
-                <a:solidFill>
-                  <a:schemeClr val="dk1"/>
-                </a:solidFill>
-                <a:latin typeface="Rubik"/>
-                <a:ea typeface="Rubik"/>
-                <a:cs typeface="Rubik"/>
-                <a:sym typeface="Rubik"/>
-              </a:rPr>
-              <a:t>وناسداك</a:t>
-            </a:r>
-            <a:r>
-              <a:rPr lang="en-US" sz="1300" b="0" i="0" u="none" strike="noStrike" cap="none" dirty="0">
-                <a:solidFill>
-                  <a:schemeClr val="dk1"/>
-                </a:solidFill>
-                <a:latin typeface="Rubik"/>
-                <a:ea typeface="Rubik"/>
-                <a:cs typeface="Rubik"/>
-                <a:sym typeface="Rubik"/>
-              </a:rPr>
-              <a:t> (NASDAQ). </a:t>
-            </a:r>
-            <a:r>
-              <a:rPr lang="en-US" sz="1300" b="0" i="1" u="none" strike="noStrike" cap="none" dirty="0" err="1">
-                <a:solidFill>
-                  <a:schemeClr val="dk1"/>
-                </a:solidFill>
-                <a:latin typeface="Rubik"/>
-                <a:ea typeface="Rubik"/>
-                <a:cs typeface="Rubik"/>
-                <a:sym typeface="Rubik"/>
-              </a:rPr>
-              <a:t>وتشكل</a:t>
-            </a:r>
-            <a:r>
-              <a:rPr lang="en-US" sz="1300" b="0" i="1" u="none" strike="noStrike" cap="none" dirty="0">
-                <a:solidFill>
-                  <a:schemeClr val="dk1"/>
-                </a:solidFill>
-                <a:latin typeface="Rubik"/>
-                <a:ea typeface="Rubik"/>
-                <a:cs typeface="Rubik"/>
-                <a:sym typeface="Rubik"/>
-              </a:rPr>
-              <a:t> </a:t>
-            </a:r>
-            <a:r>
-              <a:rPr lang="en-US" sz="1300" b="0" i="1" u="none" strike="noStrike" cap="none" dirty="0" err="1">
-                <a:solidFill>
-                  <a:schemeClr val="dk1"/>
-                </a:solidFill>
-                <a:latin typeface="Rubik"/>
-                <a:ea typeface="Rubik"/>
-                <a:cs typeface="Rubik"/>
-                <a:sym typeface="Rubik"/>
-              </a:rPr>
-              <a:t>أكبر</a:t>
-            </a:r>
-            <a:r>
-              <a:rPr lang="en-US" sz="1300" b="0" i="1" u="none" strike="noStrike" cap="none" dirty="0">
-                <a:solidFill>
-                  <a:schemeClr val="dk1"/>
-                </a:solidFill>
-                <a:latin typeface="Rubik"/>
-                <a:ea typeface="Rubik"/>
-                <a:cs typeface="Rubik"/>
-                <a:sym typeface="Rubik"/>
-              </a:rPr>
-              <a:t> 10 </a:t>
-            </a:r>
-            <a:r>
-              <a:rPr lang="en-US" sz="1300" b="0" i="1" u="none" strike="noStrike" cap="none" dirty="0" err="1">
-                <a:solidFill>
-                  <a:schemeClr val="dk1"/>
-                </a:solidFill>
-                <a:latin typeface="Rubik"/>
-                <a:ea typeface="Rubik"/>
-                <a:cs typeface="Rubik"/>
-                <a:sym typeface="Rubik"/>
-              </a:rPr>
-              <a:t>شركات</a:t>
-            </a:r>
-            <a:r>
-              <a:rPr lang="en-US" sz="1300" b="0" i="1" u="none" strike="noStrike" cap="none" dirty="0">
-                <a:solidFill>
-                  <a:schemeClr val="dk1"/>
-                </a:solidFill>
-                <a:latin typeface="Rubik"/>
-                <a:ea typeface="Rubik"/>
-                <a:cs typeface="Rubik"/>
-                <a:sym typeface="Rubik"/>
-              </a:rPr>
-              <a:t> </a:t>
-            </a:r>
-            <a:r>
-              <a:rPr lang="en-US" sz="1300" b="0" i="1" u="none" strike="noStrike" cap="none" dirty="0" err="1">
-                <a:solidFill>
-                  <a:schemeClr val="dk1"/>
-                </a:solidFill>
-                <a:latin typeface="Rubik"/>
-                <a:ea typeface="Rubik"/>
-                <a:cs typeface="Rubik"/>
-                <a:sym typeface="Rubik"/>
-              </a:rPr>
-              <a:t>في</a:t>
-            </a:r>
-            <a:r>
-              <a:rPr lang="en-US" sz="1300" b="0" i="1" u="none" strike="noStrike" cap="none" dirty="0">
-                <a:solidFill>
-                  <a:schemeClr val="dk1"/>
-                </a:solidFill>
-                <a:latin typeface="Rubik"/>
-                <a:ea typeface="Rubik"/>
-                <a:cs typeface="Rubik"/>
-                <a:sym typeface="Rubik"/>
-              </a:rPr>
-              <a:t> </a:t>
-            </a:r>
-            <a:r>
-              <a:rPr lang="en-US" sz="1300" b="0" i="1" u="none" strike="noStrike" cap="none" dirty="0" err="1">
-                <a:solidFill>
-                  <a:schemeClr val="dk1"/>
-                </a:solidFill>
-                <a:latin typeface="Rubik"/>
-                <a:ea typeface="Rubik"/>
-                <a:cs typeface="Rubik"/>
-                <a:sym typeface="Rubik"/>
-              </a:rPr>
-              <a:t>مؤشر</a:t>
-            </a:r>
-            <a:r>
-              <a:rPr lang="en-US" sz="1300" b="0" i="1" u="none" strike="noStrike" cap="none" dirty="0">
-                <a:solidFill>
-                  <a:schemeClr val="dk1"/>
-                </a:solidFill>
-                <a:latin typeface="Rubik"/>
-                <a:ea typeface="Rubik"/>
-                <a:cs typeface="Rubik"/>
-                <a:sym typeface="Rubik"/>
-              </a:rPr>
-              <a:t> S&amp;P 500 </a:t>
-            </a:r>
-            <a:r>
-              <a:rPr lang="en-US" sz="1300" b="0" i="1" u="none" strike="noStrike" cap="none" dirty="0" err="1">
-                <a:solidFill>
-                  <a:schemeClr val="dk1"/>
-                </a:solidFill>
-                <a:latin typeface="Rubik"/>
-                <a:ea typeface="Rubik"/>
-                <a:cs typeface="Rubik"/>
-                <a:sym typeface="Rubik"/>
-              </a:rPr>
-              <a:t>نحو</a:t>
-            </a:r>
-            <a:r>
-              <a:rPr lang="en-US" sz="1300" b="0" i="1" u="none" strike="noStrike" cap="none" dirty="0">
-                <a:solidFill>
-                  <a:schemeClr val="dk1"/>
-                </a:solidFill>
-                <a:latin typeface="Rubik"/>
-                <a:ea typeface="Rubik"/>
-                <a:cs typeface="Rubik"/>
-                <a:sym typeface="Rubik"/>
-              </a:rPr>
-              <a:t> 38% </a:t>
-            </a:r>
-            <a:r>
-              <a:rPr lang="en-US" sz="1300" b="0" i="1" u="none" strike="noStrike" cap="none" dirty="0" err="1">
-                <a:solidFill>
-                  <a:schemeClr val="dk1"/>
-                </a:solidFill>
-                <a:latin typeface="Rubik"/>
-                <a:ea typeface="Rubik"/>
-                <a:cs typeface="Rubik"/>
-                <a:sym typeface="Rubik"/>
-              </a:rPr>
-              <a:t>من</a:t>
-            </a:r>
-            <a:r>
-              <a:rPr lang="en-US" sz="1300" b="0" i="1" u="none" strike="noStrike" cap="none" dirty="0">
-                <a:solidFill>
-                  <a:schemeClr val="dk1"/>
-                </a:solidFill>
-                <a:latin typeface="Rubik"/>
-                <a:ea typeface="Rubik"/>
-                <a:cs typeface="Rubik"/>
-                <a:sym typeface="Rubik"/>
-              </a:rPr>
-              <a:t> </a:t>
-            </a:r>
-            <a:r>
-              <a:rPr lang="en-US" sz="1300" b="0" i="1" u="none" strike="noStrike" cap="none" dirty="0" err="1">
-                <a:solidFill>
-                  <a:schemeClr val="dk1"/>
-                </a:solidFill>
-                <a:latin typeface="Rubik"/>
-                <a:ea typeface="Rubik"/>
-                <a:cs typeface="Rubik"/>
-                <a:sym typeface="Rubik"/>
-              </a:rPr>
-              <a:t>وزن</a:t>
-            </a:r>
-            <a:r>
-              <a:rPr lang="en-US" sz="1300" b="0" i="1" u="none" strike="noStrike" cap="none" dirty="0">
-                <a:solidFill>
-                  <a:schemeClr val="dk1"/>
-                </a:solidFill>
-                <a:latin typeface="Rubik"/>
-                <a:ea typeface="Rubik"/>
-                <a:cs typeface="Rubik"/>
-                <a:sym typeface="Rubik"/>
-              </a:rPr>
-              <a:t> </a:t>
-            </a:r>
-            <a:r>
-              <a:rPr lang="en-US" sz="1300" b="0" i="1" u="none" strike="noStrike" cap="none" dirty="0" err="1">
-                <a:solidFill>
-                  <a:schemeClr val="dk1"/>
-                </a:solidFill>
-                <a:latin typeface="Rubik"/>
-                <a:ea typeface="Rubik"/>
-                <a:cs typeface="Rubik"/>
-                <a:sym typeface="Rubik"/>
-              </a:rPr>
-              <a:t>المؤشر</a:t>
+              <a:t>الفوتر (على جميع الشرائح):</a:t>
             </a:r>
             <a:endParaRPr sz="1300" b="0" i="1" u="none" strike="noStrike" cap="none" dirty="0">
               <a:solidFill>
@@ -26418,605 +26650,17 @@
               <a:buFont typeface="Arial"/>
               <a:buNone/>
             </a:pPr>
-            <a:endParaRPr sz="1300" b="0" i="1" u="none" strike="noStrike" cap="none" dirty="0">
-              <a:solidFill>
-                <a:schemeClr val="dk1"/>
-              </a:solidFill>
-              <a:latin typeface="Rubik"/>
-              <a:ea typeface="Rubik"/>
-              <a:cs typeface="Rubik"/>
-              <a:sym typeface="Rubik"/>
-            </a:endParaRPr>
-          </a:p>
-          <a:p>
-            <a:pPr marL="0" marR="0" lvl="0" indent="0" algn="r" rtl="1">
-              <a:lnSpc>
-                <a:spcPct val="115000"/>
-              </a:lnSpc>
-              <a:spcBef>
-                <a:spcPts val="0"/>
-              </a:spcBef>
-              <a:spcAft>
-                <a:spcPts val="0"/>
-              </a:spcAft>
-              <a:buClr>
-                <a:schemeClr val="dk1"/>
-              </a:buClr>
-              <a:buSzPts val="974"/>
-              <a:buFont typeface="Arial"/>
-              <a:buNone/>
-            </a:pPr>
-            <a:r>
-              <a:rPr lang="en-US" sz="1300" b="0" i="0" u="none" strike="noStrike" cap="none" dirty="0" err="1">
-                <a:solidFill>
-                  <a:schemeClr val="dk1"/>
-                </a:solidFill>
-                <a:latin typeface="Rubik Medium"/>
-                <a:ea typeface="Rubik Medium"/>
-                <a:cs typeface="Rubik Medium"/>
-                <a:sym typeface="Rubik Medium"/>
-              </a:rPr>
-              <a:t>البوست</a:t>
-            </a:r>
-            <a:r>
-              <a:rPr lang="en-US" sz="1300" b="0" i="0" u="none" strike="noStrike" cap="none" dirty="0">
-                <a:solidFill>
-                  <a:schemeClr val="dk1"/>
-                </a:solidFill>
-                <a:latin typeface="Rubik Medium"/>
-                <a:ea typeface="Rubik Medium"/>
-                <a:cs typeface="Rubik Medium"/>
-                <a:sym typeface="Rubik Medium"/>
-              </a:rPr>
-              <a:t> </a:t>
-            </a:r>
-            <a:r>
-              <a:rPr lang="en-US" sz="1300" b="0" i="0" u="none" strike="noStrike" cap="none" dirty="0" err="1">
-                <a:solidFill>
-                  <a:schemeClr val="dk1"/>
-                </a:solidFill>
-                <a:latin typeface="Rubik Medium"/>
-                <a:ea typeface="Rubik Medium"/>
-                <a:cs typeface="Rubik Medium"/>
-                <a:sym typeface="Rubik Medium"/>
-              </a:rPr>
-              <a:t>الخامس</a:t>
-            </a:r>
-            <a:r>
-              <a:rPr lang="en-US" sz="1300" b="0" i="0" u="none" strike="noStrike" cap="none" dirty="0">
-                <a:solidFill>
-                  <a:schemeClr val="dk1"/>
-                </a:solidFill>
-                <a:latin typeface="Rubik Medium"/>
-                <a:ea typeface="Rubik Medium"/>
-                <a:cs typeface="Rubik Medium"/>
-                <a:sym typeface="Rubik Medium"/>
-              </a:rPr>
-              <a:t>: </a:t>
-            </a:r>
-            <a:endParaRPr sz="1300" b="0" i="1" u="none" strike="noStrike" cap="none" dirty="0">
-              <a:solidFill>
-                <a:schemeClr val="dk1"/>
-              </a:solidFill>
-              <a:latin typeface="Rubik"/>
-              <a:ea typeface="Rubik"/>
-              <a:cs typeface="Rubik"/>
-              <a:sym typeface="Rubik"/>
-            </a:endParaRPr>
-          </a:p>
-          <a:p>
-            <a:pPr marL="0" marR="0" lvl="0" indent="0" algn="r" rtl="1">
-              <a:lnSpc>
-                <a:spcPct val="115000"/>
-              </a:lnSpc>
-              <a:spcBef>
-                <a:spcPts val="0"/>
-              </a:spcBef>
-              <a:spcAft>
-                <a:spcPts val="0"/>
-              </a:spcAft>
-              <a:buClr>
-                <a:schemeClr val="dk1"/>
-              </a:buClr>
-              <a:buSzPts val="1100"/>
-              <a:buFont typeface="Arial"/>
-              <a:buNone/>
-            </a:pPr>
-            <a:r>
-              <a:rPr lang="en-US" sz="1300" b="0" i="0" u="none" strike="noStrike" cap="none" dirty="0" err="1">
-                <a:solidFill>
-                  <a:schemeClr val="dk1"/>
-                </a:solidFill>
-                <a:latin typeface="Rubik"/>
-                <a:ea typeface="Rubik"/>
-                <a:cs typeface="Rubik"/>
-                <a:sym typeface="Rubik"/>
-              </a:rPr>
-              <a:t>البداية</a:t>
-            </a:r>
-            <a:r>
-              <a:rPr lang="en-US" sz="1300" b="0" i="0" u="none" strike="noStrike" cap="none" dirty="0">
-                <a:solidFill>
-                  <a:schemeClr val="dk1"/>
-                </a:solidFill>
-                <a:latin typeface="Rubik"/>
-                <a:ea typeface="Rubik"/>
-                <a:cs typeface="Rubik"/>
-                <a:sym typeface="Rubik"/>
-              </a:rPr>
-              <a:t> </a:t>
-            </a:r>
-            <a:r>
-              <a:rPr lang="en-US" sz="1300" b="0" i="0" u="none" strike="noStrike" cap="none" dirty="0" err="1">
-                <a:solidFill>
-                  <a:schemeClr val="dk1"/>
-                </a:solidFill>
-                <a:latin typeface="Rubik"/>
-                <a:ea typeface="Rubik"/>
-                <a:cs typeface="Rubik"/>
-                <a:sym typeface="Rubik"/>
-              </a:rPr>
-              <a:t>أسهل</a:t>
-            </a:r>
-            <a:r>
-              <a:rPr lang="en-US" sz="1300" b="0" i="0" u="none" strike="noStrike" cap="none" dirty="0">
-                <a:solidFill>
-                  <a:schemeClr val="dk1"/>
-                </a:solidFill>
-                <a:latin typeface="Rubik"/>
-                <a:ea typeface="Rubik"/>
-                <a:cs typeface="Rubik"/>
-                <a:sym typeface="Rubik"/>
-              </a:rPr>
-              <a:t> </a:t>
-            </a:r>
-            <a:r>
-              <a:rPr lang="en-US" sz="1300" b="0" i="0" u="none" strike="noStrike" cap="none" dirty="0" err="1">
-                <a:solidFill>
-                  <a:schemeClr val="dk1"/>
-                </a:solidFill>
-                <a:latin typeface="Rubik"/>
-                <a:ea typeface="Rubik"/>
-                <a:cs typeface="Rubik"/>
-                <a:sym typeface="Rubik"/>
-              </a:rPr>
-              <a:t>ممّا</a:t>
-            </a:r>
-            <a:r>
-              <a:rPr lang="en-US" sz="1300" b="0" i="0" u="none" strike="noStrike" cap="none" dirty="0">
-                <a:solidFill>
-                  <a:schemeClr val="dk1"/>
-                </a:solidFill>
-                <a:latin typeface="Rubik"/>
-                <a:ea typeface="Rubik"/>
-                <a:cs typeface="Rubik"/>
-                <a:sym typeface="Rubik"/>
-              </a:rPr>
-              <a:t> </a:t>
-            </a:r>
-            <a:r>
-              <a:rPr lang="en-US" sz="1300" b="0" i="0" u="none" strike="noStrike" cap="none" dirty="0" err="1">
-                <a:solidFill>
-                  <a:schemeClr val="dk1"/>
-                </a:solidFill>
-                <a:latin typeface="Rubik"/>
-                <a:ea typeface="Rubik"/>
-                <a:cs typeface="Rubik"/>
-                <a:sym typeface="Rubik"/>
-              </a:rPr>
-              <a:t>تتخيل</a:t>
-            </a:r>
-            <a:r>
-              <a:rPr lang="en-US" sz="1300" b="0" i="0" u="none" strike="noStrike" cap="none" dirty="0">
-                <a:solidFill>
-                  <a:schemeClr val="dk1"/>
-                </a:solidFill>
-                <a:latin typeface="Rubik"/>
-                <a:ea typeface="Rubik"/>
-                <a:cs typeface="Rubik"/>
-                <a:sym typeface="Rubik"/>
-              </a:rPr>
-              <a:t>! 💡</a:t>
-            </a:r>
-            <a:endParaRPr sz="1300" b="0" i="0" u="none" strike="noStrike" cap="none" dirty="0">
-              <a:solidFill>
-                <a:schemeClr val="dk1"/>
-              </a:solidFill>
-              <a:latin typeface="Rubik"/>
-              <a:ea typeface="Rubik"/>
-              <a:cs typeface="Rubik"/>
-              <a:sym typeface="Rubik"/>
-            </a:endParaRPr>
-          </a:p>
-          <a:p>
-            <a:pPr marL="0" marR="0" lvl="0" indent="0" algn="r" rtl="1">
-              <a:lnSpc>
-                <a:spcPct val="115000"/>
-              </a:lnSpc>
-              <a:spcBef>
-                <a:spcPts val="0"/>
-              </a:spcBef>
-              <a:spcAft>
-                <a:spcPts val="0"/>
-              </a:spcAft>
-              <a:buClr>
-                <a:schemeClr val="dk1"/>
-              </a:buClr>
-              <a:buSzPts val="1100"/>
-              <a:buFont typeface="Arial"/>
-              <a:buNone/>
-            </a:pPr>
-            <a:r>
-              <a:rPr lang="en-US" sz="1300" b="0" i="0" u="none" strike="noStrike" cap="none" dirty="0" err="1">
-                <a:solidFill>
-                  <a:schemeClr val="dk1"/>
-                </a:solidFill>
-                <a:latin typeface="Rubik"/>
-                <a:ea typeface="Rubik"/>
-                <a:cs typeface="Rubik"/>
-                <a:sym typeface="Rubik"/>
-              </a:rPr>
-              <a:t>استكشف</a:t>
-            </a:r>
-            <a:r>
-              <a:rPr lang="en-US" sz="1300" b="0" i="0" u="none" strike="noStrike" cap="none" dirty="0">
-                <a:solidFill>
-                  <a:schemeClr val="dk1"/>
-                </a:solidFill>
-                <a:latin typeface="Rubik"/>
-                <a:ea typeface="Rubik"/>
-                <a:cs typeface="Rubik"/>
-                <a:sym typeface="Rubik"/>
-              </a:rPr>
-              <a:t> </a:t>
-            </a:r>
-            <a:r>
-              <a:rPr lang="en-US" sz="1300" b="0" i="0" u="none" strike="noStrike" cap="none" dirty="0" err="1">
-                <a:solidFill>
-                  <a:schemeClr val="dk1"/>
-                </a:solidFill>
-                <a:latin typeface="Rubik"/>
-                <a:ea typeface="Rubik"/>
-                <a:cs typeface="Rubik"/>
-                <a:sym typeface="Rubik"/>
-              </a:rPr>
-              <a:t>مجموعة</a:t>
-            </a:r>
-            <a:r>
-              <a:rPr lang="en-US" sz="1300" b="0" i="0" u="none" strike="noStrike" cap="none" dirty="0">
-                <a:solidFill>
-                  <a:schemeClr val="dk1"/>
-                </a:solidFill>
-                <a:latin typeface="Rubik"/>
-                <a:ea typeface="Rubik"/>
-                <a:cs typeface="Rubik"/>
-                <a:sym typeface="Rubik"/>
-              </a:rPr>
-              <a:t> </a:t>
-            </a:r>
-            <a:r>
-              <a:rPr lang="en-US" sz="1300" b="0" i="0" u="none" strike="noStrike" cap="none" dirty="0" err="1">
-                <a:solidFill>
-                  <a:schemeClr val="dk1"/>
-                </a:solidFill>
-                <a:latin typeface="Rubik"/>
-                <a:ea typeface="Rubik"/>
-                <a:cs typeface="Rubik"/>
-                <a:sym typeface="Rubik"/>
-              </a:rPr>
-              <a:t>مختارة</a:t>
-            </a:r>
-            <a:r>
-              <a:rPr lang="en-US" sz="1300" b="0" i="0" u="none" strike="noStrike" cap="none" dirty="0">
-                <a:solidFill>
-                  <a:schemeClr val="dk1"/>
-                </a:solidFill>
-                <a:latin typeface="Rubik"/>
-                <a:ea typeface="Rubik"/>
-                <a:cs typeface="Rubik"/>
-                <a:sym typeface="Rubik"/>
-              </a:rPr>
-              <a:t> </a:t>
-            </a:r>
-            <a:r>
-              <a:rPr lang="en-US" sz="1300" b="0" i="0" u="none" strike="noStrike" cap="none" dirty="0" err="1">
-                <a:solidFill>
-                  <a:schemeClr val="dk1"/>
-                </a:solidFill>
-                <a:latin typeface="Rubik"/>
-                <a:ea typeface="Rubik"/>
-                <a:cs typeface="Rubik"/>
-                <a:sym typeface="Rubik"/>
-              </a:rPr>
-              <a:t>من</a:t>
-            </a:r>
-            <a:r>
-              <a:rPr lang="en-US" sz="1300" b="0" i="0" u="none" strike="noStrike" cap="none" dirty="0">
-                <a:solidFill>
-                  <a:schemeClr val="dk1"/>
-                </a:solidFill>
-                <a:latin typeface="Rubik"/>
-                <a:ea typeface="Rubik"/>
-                <a:cs typeface="Rubik"/>
-                <a:sym typeface="Rubik"/>
-              </a:rPr>
-              <a:t> </a:t>
-            </a:r>
-            <a:r>
-              <a:rPr lang="en-US" sz="1300" b="0" i="0" u="none" strike="noStrike" cap="none" dirty="0" err="1">
-                <a:solidFill>
-                  <a:schemeClr val="dk1"/>
-                </a:solidFill>
-                <a:latin typeface="Rubik"/>
-                <a:ea typeface="Rubik"/>
-                <a:cs typeface="Rubik"/>
-                <a:sym typeface="Rubik"/>
-              </a:rPr>
-              <a:t>الأسهم</a:t>
-            </a:r>
-            <a:r>
-              <a:rPr lang="en-US" sz="1300" b="0" i="0" u="none" strike="noStrike" cap="none" dirty="0">
-                <a:solidFill>
-                  <a:schemeClr val="dk1"/>
-                </a:solidFill>
-                <a:latin typeface="Rubik"/>
-                <a:ea typeface="Rubik"/>
-                <a:cs typeface="Rubik"/>
-                <a:sym typeface="Rubik"/>
-              </a:rPr>
-              <a:t> </a:t>
-            </a:r>
-            <a:r>
-              <a:rPr lang="en-US" sz="1300" b="0" i="0" u="none" strike="noStrike" cap="none" dirty="0" err="1">
-                <a:solidFill>
-                  <a:schemeClr val="dk1"/>
-                </a:solidFill>
-                <a:latin typeface="Rubik"/>
-                <a:ea typeface="Rubik"/>
-                <a:cs typeface="Rubik"/>
-                <a:sym typeface="Rubik"/>
-              </a:rPr>
-              <a:t>الأمريكية</a:t>
-            </a:r>
-            <a:r>
-              <a:rPr lang="en-US" sz="1300" b="0" i="0" u="none" strike="noStrike" cap="none" dirty="0">
-                <a:solidFill>
-                  <a:schemeClr val="dk1"/>
-                </a:solidFill>
-                <a:latin typeface="Rubik"/>
-                <a:ea typeface="Rubik"/>
-                <a:cs typeface="Rubik"/>
-                <a:sym typeface="Rubik"/>
-              </a:rPr>
-              <a:t> </a:t>
-            </a:r>
-            <a:r>
-              <a:rPr lang="en-US" sz="1300" b="0" i="0" u="none" strike="noStrike" cap="none" dirty="0" err="1">
-                <a:solidFill>
-                  <a:schemeClr val="dk1"/>
-                </a:solidFill>
-                <a:latin typeface="Rubik"/>
-                <a:ea typeface="Rubik"/>
-                <a:cs typeface="Rubik"/>
-                <a:sym typeface="Rubik"/>
-              </a:rPr>
-              <a:t>عبر</a:t>
-            </a:r>
-            <a:r>
-              <a:rPr lang="en-US" sz="1300" b="0" i="0" u="none" strike="noStrike" cap="none" dirty="0">
-                <a:solidFill>
-                  <a:schemeClr val="dk1"/>
-                </a:solidFill>
-                <a:latin typeface="Rubik"/>
-                <a:ea typeface="Rubik"/>
-                <a:cs typeface="Rubik"/>
-                <a:sym typeface="Rubik"/>
-              </a:rPr>
-              <a:t> </a:t>
-            </a:r>
-            <a:r>
-              <a:rPr lang="en-US" sz="1300" b="0" i="0" u="none" strike="noStrike" cap="none" dirty="0" err="1">
-                <a:solidFill>
-                  <a:schemeClr val="dk1"/>
-                </a:solidFill>
-                <a:latin typeface="Rubik"/>
-                <a:ea typeface="Rubik"/>
-                <a:cs typeface="Rubik"/>
-                <a:sym typeface="Rubik"/>
-              </a:rPr>
-              <a:t>تطبيق</a:t>
-            </a:r>
-            <a:r>
-              <a:rPr lang="en-US" sz="1300" b="0" i="0" u="none" strike="noStrike" cap="none" dirty="0">
-                <a:solidFill>
-                  <a:schemeClr val="dk1"/>
-                </a:solidFill>
-                <a:latin typeface="Rubik"/>
-                <a:ea typeface="Rubik"/>
-                <a:cs typeface="Rubik"/>
-                <a:sym typeface="Rubik"/>
-              </a:rPr>
-              <a:t> </a:t>
-            </a:r>
-            <a:r>
-              <a:rPr lang="en-US" sz="1300" b="0" i="0" u="none" strike="noStrike" cap="none" dirty="0" err="1">
-                <a:solidFill>
-                  <a:schemeClr val="dk1"/>
-                </a:solidFill>
-                <a:latin typeface="Rubik"/>
-                <a:ea typeface="Rubik"/>
-                <a:cs typeface="Rubik"/>
-                <a:sym typeface="Rubik"/>
-              </a:rPr>
-              <a:t>eMYAA</a:t>
-            </a:r>
-            <a:r>
-              <a:rPr lang="en-US" sz="1300" b="0" i="0" u="none" strike="noStrike" cap="none" dirty="0">
-                <a:solidFill>
-                  <a:schemeClr val="dk1"/>
-                </a:solidFill>
-                <a:latin typeface="Rubik"/>
-                <a:ea typeface="Rubik"/>
-                <a:cs typeface="Rubik"/>
-                <a:sym typeface="Rubik"/>
-              </a:rPr>
-              <a:t>، </a:t>
-            </a:r>
-            <a:r>
-              <a:rPr lang="en-US" sz="1300" b="0" i="0" u="none" strike="noStrike" cap="none" dirty="0" err="1">
-                <a:solidFill>
-                  <a:schemeClr val="dk1"/>
-                </a:solidFill>
-                <a:latin typeface="Rubik"/>
-                <a:ea typeface="Rubik"/>
-                <a:cs typeface="Rubik"/>
-                <a:sym typeface="Rubik"/>
-              </a:rPr>
-              <a:t>بحد</a:t>
-            </a:r>
-            <a:r>
-              <a:rPr lang="en-US" sz="1300" b="0" i="0" u="none" strike="noStrike" cap="none" dirty="0">
-                <a:solidFill>
-                  <a:schemeClr val="dk1"/>
-                </a:solidFill>
-                <a:latin typeface="Rubik"/>
-                <a:ea typeface="Rubik"/>
-                <a:cs typeface="Rubik"/>
-                <a:sym typeface="Rubik"/>
-              </a:rPr>
-              <a:t> </a:t>
-            </a:r>
-            <a:r>
-              <a:rPr lang="en-US" sz="1300" b="0" i="0" u="none" strike="noStrike" cap="none" dirty="0" err="1">
-                <a:solidFill>
-                  <a:schemeClr val="dk1"/>
-                </a:solidFill>
-                <a:latin typeface="Rubik"/>
-                <a:ea typeface="Rubik"/>
-                <a:cs typeface="Rubik"/>
-                <a:sym typeface="Rubik"/>
-              </a:rPr>
-              <a:t>أدنى</a:t>
-            </a:r>
-            <a:r>
-              <a:rPr lang="en-US" sz="1300" b="0" i="0" u="none" strike="noStrike" cap="none" dirty="0">
-                <a:solidFill>
-                  <a:schemeClr val="dk1"/>
-                </a:solidFill>
-                <a:latin typeface="Rubik"/>
-                <a:ea typeface="Rubik"/>
-                <a:cs typeface="Rubik"/>
-                <a:sym typeface="Rubik"/>
-              </a:rPr>
-              <a:t> </a:t>
-            </a:r>
-            <a:r>
-              <a:rPr lang="en-US" sz="1300" b="0" i="0" u="none" strike="noStrike" cap="none" dirty="0" err="1">
-                <a:solidFill>
-                  <a:schemeClr val="dk1"/>
-                </a:solidFill>
-                <a:latin typeface="Rubik"/>
-                <a:ea typeface="Rubik"/>
-                <a:cs typeface="Rubik"/>
-                <a:sym typeface="Rubik"/>
-              </a:rPr>
-              <a:t>للإيداع</a:t>
-            </a:r>
-            <a:r>
-              <a:rPr lang="en-US" sz="1300" b="0" i="0" u="none" strike="noStrike" cap="none" dirty="0">
-                <a:solidFill>
-                  <a:schemeClr val="dk1"/>
-                </a:solidFill>
-                <a:latin typeface="Rubik"/>
-                <a:ea typeface="Rubik"/>
-                <a:cs typeface="Rubik"/>
-                <a:sym typeface="Rubik"/>
-              </a:rPr>
-              <a:t> </a:t>
-            </a:r>
-            <a:r>
-              <a:rPr lang="en-US" sz="1300" b="0" i="0" u="none" strike="noStrike" cap="none" dirty="0" err="1">
-                <a:solidFill>
-                  <a:schemeClr val="dk1"/>
-                </a:solidFill>
-                <a:latin typeface="Rubik"/>
-                <a:ea typeface="Rubik"/>
-                <a:cs typeface="Rubik"/>
-                <a:sym typeface="Rubik"/>
-              </a:rPr>
-              <a:t>يبدأ</a:t>
-            </a:r>
-            <a:r>
-              <a:rPr lang="en-US" sz="1300" b="0" i="0" u="none" strike="noStrike" cap="none" dirty="0">
-                <a:solidFill>
-                  <a:schemeClr val="dk1"/>
-                </a:solidFill>
-                <a:latin typeface="Rubik"/>
-                <a:ea typeface="Rubik"/>
-                <a:cs typeface="Rubik"/>
-                <a:sym typeface="Rubik"/>
-              </a:rPr>
-              <a:t> </a:t>
-            </a:r>
-            <a:r>
-              <a:rPr lang="en-US" sz="1300" b="0" i="0" u="none" strike="noStrike" cap="none" dirty="0" err="1">
-                <a:solidFill>
-                  <a:schemeClr val="dk1"/>
-                </a:solidFill>
-                <a:latin typeface="Rubik"/>
-                <a:ea typeface="Rubik"/>
-                <a:cs typeface="Rubik"/>
-                <a:sym typeface="Rubik"/>
-              </a:rPr>
-              <a:t>من</a:t>
-            </a:r>
-            <a:r>
-              <a:rPr lang="en-US" sz="1300" b="0" i="0" u="none" strike="noStrike" cap="none" dirty="0">
-                <a:solidFill>
-                  <a:schemeClr val="dk1"/>
-                </a:solidFill>
-                <a:latin typeface="Rubik"/>
-                <a:ea typeface="Rubik"/>
-                <a:cs typeface="Rubik"/>
-                <a:sym typeface="Rubik"/>
-              </a:rPr>
-              <a:t> 50 </a:t>
-            </a:r>
-            <a:r>
-              <a:rPr lang="en-US" sz="1300" b="0" i="0" u="none" strike="noStrike" cap="none" dirty="0" err="1">
-                <a:solidFill>
-                  <a:schemeClr val="dk1"/>
-                </a:solidFill>
-                <a:latin typeface="Rubik"/>
-                <a:ea typeface="Rubik"/>
-                <a:cs typeface="Rubik"/>
-                <a:sym typeface="Rubik"/>
-              </a:rPr>
-              <a:t>دولاراً</a:t>
-            </a:r>
-            <a:r>
-              <a:rPr lang="en-US" sz="1300" b="0" i="0" u="none" strike="noStrike" cap="none" dirty="0">
-                <a:solidFill>
-                  <a:schemeClr val="dk1"/>
-                </a:solidFill>
-                <a:latin typeface="Rubik"/>
-                <a:ea typeface="Rubik"/>
-                <a:cs typeface="Rubik"/>
-                <a:sym typeface="Rubik"/>
-              </a:rPr>
-              <a:t> </a:t>
-            </a:r>
-            <a:r>
-              <a:rPr lang="en-US" sz="1300" b="0" i="0" u="none" strike="noStrike" cap="none" dirty="0" err="1">
-                <a:solidFill>
-                  <a:schemeClr val="dk1"/>
-                </a:solidFill>
-                <a:latin typeface="Rubik"/>
-                <a:ea typeface="Rubik"/>
-                <a:cs typeface="Rubik"/>
-                <a:sym typeface="Rubik"/>
-              </a:rPr>
-              <a:t>فقط</a:t>
+            <a:r>
+              <a:rPr lang="en-US" sz="1150" b="0" i="1" u="none" strike="noStrike" cap="none" dirty="0" err="1">
+                <a:solidFill>
+                  <a:schemeClr val="dk1"/>
+                </a:solidFill>
+                <a:latin typeface="Rubik"/>
+                <a:ea typeface="Rubik"/>
+                <a:cs typeface="Rubik"/>
+                <a:sym typeface="Rubik"/>
+              </a:rPr>
+              <a:t>المصدر: SIFMA - Capital Markets Fact Book 2026. البيانات حتى عام 2025. لأغراض توعوية فقط، ولا تُعد نصيحة استثمارية.</a:t>
             </a:r>
             <a:endParaRPr sz="1300" b="0" i="0" u="none" strike="noStrike" cap="none" dirty="0">
               <a:solidFill>
@@ -27370,7 +27014,7 @@
           </a:ln>
         </p:spPr>
         <p:txBody>
-          <a:bodyPr spcFirstLastPara="1" wrap="square" lIns="0" tIns="0" rIns="0" bIns="0" anchor="ctr" anchorCtr="0">
+          <a:bodyPr spcFirstLastPara="1" wrap="square" lIns="0" tIns="0" rIns="0" bIns="0" anchor="t" anchorCtr="0">
             <a:spAutoFit/>
           </a:bodyPr>
           <a:lstStyle/>
@@ -27393,7 +27037,7 @@
               <a:buNone/>
             </a:pPr>
             <a:r>
-              <a:rPr lang="en-US" sz="1300" b="0" i="0" u="none" strike="noStrike" cap="none" dirty="0">
+              <a:rPr lang="en-US" sz="1150" b="0" i="0" u="none" strike="noStrike" cap="none" dirty="0">
                 <a:solidFill>
                   <a:schemeClr val="dk1"/>
                 </a:solidFill>
@@ -27433,7 +27077,7 @@
               <a:buNone/>
             </a:pPr>
             <a:r>
-              <a:rPr lang="en-US" sz="1300" b="0" i="0" u="none" strike="noStrike" cap="none" dirty="0">
+              <a:rPr lang="en-US" sz="1150" b="0" i="0" u="none" strike="noStrike" cap="none" dirty="0">
                 <a:solidFill>
                   <a:schemeClr val="dk1"/>
                 </a:solidFill>
@@ -27501,7 +27145,7 @@
               <a:buNone/>
             </a:pPr>
             <a:r>
-              <a:rPr lang="en-US" sz="1300" b="0" i="0" u="none" strike="noStrike" cap="none" dirty="0">
+              <a:rPr lang="en-US" sz="1150" b="0" i="0" u="none" strike="noStrike" cap="none" dirty="0">
                 <a:solidFill>
                   <a:schemeClr val="dk1"/>
                 </a:solidFill>
@@ -27541,7 +27185,7 @@
               <a:buNone/>
             </a:pPr>
             <a:r>
-              <a:rPr lang="en-US" sz="1300" b="0" i="0" u="none" strike="noStrike" cap="none" dirty="0">
+              <a:rPr lang="en-US" sz="1150" b="0" i="0" u="none" strike="noStrike" cap="none" dirty="0">
                 <a:solidFill>
                   <a:schemeClr val="dk1"/>
                 </a:solidFill>
@@ -27581,7 +27225,7 @@
               <a:buNone/>
             </a:pPr>
             <a:r>
-              <a:rPr lang="en-US" sz="1300" b="0" i="0" u="none" strike="noStrike" cap="none" dirty="0">
+              <a:rPr lang="en-US" sz="1150" b="0" i="0" u="none" strike="noStrike" cap="none" dirty="0">
                 <a:solidFill>
                   <a:schemeClr val="dk1"/>
                 </a:solidFill>
@@ -27620,8 +27264,76 @@
               <a:buFont typeface="Arial"/>
               <a:buNone/>
             </a:pPr>
-            <a:r>
-              <a:rPr lang="en-US" sz="1300" b="0" i="1" u="none" strike="noStrike" cap="none" dirty="0">
+            <a:endParaRPr sz="1300" b="0" i="0" u="none" strike="noStrike" cap="none" dirty="0">
+              <a:solidFill>
+                <a:schemeClr val="dk1"/>
+              </a:solidFill>
+              <a:latin typeface="Montserrat SemiBold"/>
+              <a:ea typeface="Montserrat SemiBold"/>
+              <a:cs typeface="Montserrat SemiBold"/>
+              <a:sym typeface="Montserrat SemiBold"/>
+            </a:endParaRPr>
+          </a:p>
+          <a:p>
+            <a:pPr marL="0" marR="0" lvl="0" indent="0" algn="l" rtl="0">
+              <a:lnSpc>
+                <a:spcPct val="115000"/>
+              </a:lnSpc>
+              <a:spcBef>
+                <a:spcPts val="0"/>
+              </a:spcBef>
+              <a:spcAft>
+                <a:spcPts val="0"/>
+              </a:spcAft>
+              <a:buClr>
+                <a:schemeClr val="dk1"/>
+              </a:buClr>
+              <a:buSzPts val="1100"/>
+              <a:buFont typeface="Arial"/>
+              <a:buNone/>
+            </a:pPr>
+            <a:r>
+              <a:rPr lang="en-US" sz="1150" b="0" i="0" u="none" strike="noStrike" cap="none" dirty="0">
+                <a:solidFill>
+                  <a:schemeClr val="dk1"/>
+                </a:solidFill>
+                <a:latin typeface="Montserrat SemiBold"/>
+                <a:ea typeface="Montserrat SemiBold"/>
+                <a:cs typeface="Montserrat SemiBold"/>
+                <a:sym typeface="Montserrat SemiBold"/>
+              </a:rPr>
+              <a:t>Post 3: </a:t>
+            </a:r>
+            <a:endParaRPr sz="1300" b="0" i="0" u="none" strike="noStrike" cap="none" dirty="0">
+              <a:solidFill>
+                <a:schemeClr val="dk1"/>
+              </a:solidFill>
+              <a:latin typeface="Arial"/>
+              <a:ea typeface="Arial"/>
+              <a:cs typeface="Arial"/>
+              <a:sym typeface="Arial"/>
+            </a:endParaRPr>
+          </a:p>
+          <a:p>
+            <a:pPr marL="0" marR="0" lvl="0" indent="0" algn="l" rtl="0">
+              <a:lnSpc>
+                <a:spcPct val="115000"/>
+              </a:lnSpc>
+              <a:spcBef>
+                <a:spcPts val="0"/>
+              </a:spcBef>
+              <a:spcAft>
+                <a:spcPts val="0"/>
+              </a:spcAft>
+              <a:buClr>
+                <a:schemeClr val="dk1"/>
+              </a:buClr>
+              <a:buSzPts val="1100"/>
+              <a:buFont typeface="Arial"/>
+              <a:buNone/>
+            </a:pPr>
+            <a:r>
+              <a:rPr lang="en-US" sz="1150" b="0" i="0" u="none" strike="noStrike" cap="none" dirty="0">
                 <a:solidFill>
                   <a:schemeClr val="dk1"/>
                 </a:solidFill>
@@ -27630,7 +27342,7 @@
                 <a:cs typeface="Montserrat"/>
                 <a:sym typeface="Montserrat"/>
               </a:rPr>
-              <a:t>Source: SIFMA Capital Markets Fact Book 2026</a:t>
+              <a:t>Unmatched Financial Power 💰</a:t>
             </a:r>
             <a:endParaRPr sz="1300" b="0" i="0" u="none" strike="noStrike" cap="none" dirty="0">
               <a:solidFill>
@@ -27660,6 +27372,46 @@
               <a:buFont typeface="Arial"/>
               <a:buNone/>
             </a:pPr>
+            <a:r>
+              <a:rPr lang="en-US" sz="1150" b="0" i="0" u="none" strike="noStrike" cap="none" dirty="0">
+                <a:solidFill>
+                  <a:schemeClr val="dk1"/>
+                </a:solidFill>
+                <a:latin typeface="Montserrat"/>
+                <a:ea typeface="Montserrat"/>
+                <a:cs typeface="Montserrat"/>
+                <a:sym typeface="Montserrat"/>
+              </a:rPr>
+              <a:t>The market capitalization of U.S. equity markets reached $68.9 trillion last year, 4.4 times the size of China's market, the world's second largest.</a:t>
+            </a:r>
+            <a:endParaRPr sz="1300" b="0" i="0" u="none" strike="noStrike" cap="none" dirty="0">
+              <a:solidFill>
+                <a:schemeClr val="dk1"/>
+              </a:solidFill>
+              <a:latin typeface="Montserrat"/>
+              <a:ea typeface="Montserrat"/>
+              <a:cs typeface="Montserrat"/>
+              <a:sym typeface="Montserrat"/>
+            </a:endParaRPr>
+          </a:p>
+          <a:p>
+            <a:pPr marL="0" marR="0" lvl="0" indent="0" algn="l" rtl="0">
+              <a:lnSpc>
+                <a:spcPct val="115000"/>
+              </a:lnSpc>
+              <a:spcBef>
+                <a:spcPts val="0"/>
+              </a:spcBef>
+              <a:spcAft>
+                <a:spcPts val="0"/>
+              </a:spcAft>
+              <a:buClr>
+                <a:schemeClr val="dk1"/>
+              </a:buClr>
+              <a:buSzPts val="1100"/>
+              <a:buFont typeface="Arial"/>
+              <a:buNone/>
+            </a:pPr>
             <a:endParaRPr sz="1300" b="0" i="0" u="none" strike="noStrike" cap="none" dirty="0">
               <a:solidFill>
                 <a:schemeClr val="dk1"/>
@@ -27689,7 +27441,7 @@
               <a:buNone/>
             </a:pPr>
             <a:r>
-              <a:rPr lang="en-US" sz="1300" b="0" i="0" u="none" strike="noStrike" cap="none" dirty="0">
+              <a:rPr lang="en-US" sz="1150" b="0" i="0" u="none" strike="noStrike" cap="none" dirty="0">
                 <a:solidFill>
                   <a:schemeClr val="dk1"/>
                 </a:solidFill>
@@ -27698,16 +27450,16 @@
                 <a:cs typeface="Montserrat SemiBold"/>
                 <a:sym typeface="Montserrat SemiBold"/>
               </a:rPr>
-              <a:t>Post 3: </a:t>
+              <a:t>Post 4: </a:t>
             </a:r>
             <a:endParaRPr sz="1300" b="0" i="0" u="none" strike="noStrike" cap="none" dirty="0">
               <a:solidFill>
                 <a:schemeClr val="dk1"/>
               </a:solidFill>
-              <a:latin typeface="Arial"/>
-              <a:ea typeface="Arial"/>
-              <a:cs typeface="Arial"/>
-              <a:sym typeface="Arial"/>
+              <a:latin typeface="Montserrat SemiBold"/>
+              <a:ea typeface="Montserrat SemiBold"/>
+              <a:cs typeface="Montserrat SemiBold"/>
+              <a:sym typeface="Montserrat SemiBold"/>
             </a:endParaRPr>
           </a:p>
           <a:p>
@@ -27729,7 +27481,7 @@
               <a:buNone/>
             </a:pPr>
             <a:r>
-              <a:rPr lang="en-US" sz="1300" b="0" i="0" u="none" strike="noStrike" cap="none" dirty="0">
+              <a:rPr lang="en-US" sz="1150" b="0" i="0" u="none" strike="noStrike" cap="none" dirty="0">
                 <a:solidFill>
                   <a:schemeClr val="dk1"/>
                 </a:solidFill>
@@ -27738,7 +27490,7 @@
                 <a:cs typeface="Montserrat"/>
                 <a:sym typeface="Montserrat"/>
               </a:rPr>
-              <a:t>Unmatched Financial Power 💰</a:t>
+              <a:t>Diverse Investment Options 🏢</a:t>
             </a:r>
             <a:endParaRPr sz="1300" b="0" i="0" u="none" strike="noStrike" cap="none" dirty="0">
               <a:solidFill>
@@ -27769,7 +27521,7 @@
               <a:buNone/>
             </a:pPr>
             <a:r>
-              <a:rPr lang="en-US" sz="1300" b="0" i="0" u="none" strike="noStrike" cap="none" dirty="0">
+              <a:rPr lang="en-US" sz="1150" b="0" i="0" u="none" strike="noStrike" cap="none" dirty="0">
                 <a:solidFill>
                   <a:schemeClr val="dk1"/>
                 </a:solidFill>
@@ -27778,7 +27530,7 @@
                 <a:cs typeface="Montserrat"/>
                 <a:sym typeface="Montserrat"/>
               </a:rPr>
-              <a:t>The market capitalization of U.S. equity markets reached $68.9 trillion last year, 4.4 times the size of China's market, the world's second largest.</a:t>
+              <a:t>More than 5,500 companies are listed on the New York Stock Exchange (NYSE) and NASDAQ, giving you a wide choice of sectors and companies.</a:t>
             </a:r>
             <a:endParaRPr sz="1300" b="0" i="0" u="none" strike="noStrike" cap="none" dirty="0">
               <a:solidFill>
@@ -27808,8 +27560,76 @@
               <a:buFont typeface="Arial"/>
               <a:buNone/>
             </a:pPr>
-            <a:r>
-              <a:rPr lang="en-US" sz="1300" b="0" i="1" u="none" strike="noStrike" cap="none" dirty="0">
+            <a:endParaRPr sz="1300" b="0" i="0" u="none" strike="noStrike" cap="none" dirty="0">
+              <a:solidFill>
+                <a:schemeClr val="dk1"/>
+              </a:solidFill>
+              <a:latin typeface="Montserrat SemiBold"/>
+              <a:ea typeface="Montserrat SemiBold"/>
+              <a:cs typeface="Montserrat SemiBold"/>
+              <a:sym typeface="Montserrat SemiBold"/>
+            </a:endParaRPr>
+          </a:p>
+          <a:p>
+            <a:pPr marL="0" marR="0" lvl="0" indent="0" algn="l" rtl="0">
+              <a:lnSpc>
+                <a:spcPct val="115000"/>
+              </a:lnSpc>
+              <a:spcBef>
+                <a:spcPts val="0"/>
+              </a:spcBef>
+              <a:spcAft>
+                <a:spcPts val="0"/>
+              </a:spcAft>
+              <a:buClr>
+                <a:schemeClr val="dk1"/>
+              </a:buClr>
+              <a:buSzPts val="1100"/>
+              <a:buFont typeface="Arial"/>
+              <a:buNone/>
+            </a:pPr>
+            <a:r>
+              <a:rPr lang="en-US" sz="1150" b="0" i="0" u="none" strike="noStrike" cap="none" dirty="0">
+                <a:solidFill>
+                  <a:schemeClr val="dk1"/>
+                </a:solidFill>
+                <a:latin typeface="Montserrat SemiBold"/>
+                <a:ea typeface="Montserrat SemiBold"/>
+                <a:cs typeface="Montserrat SemiBold"/>
+                <a:sym typeface="Montserrat SemiBold"/>
+              </a:rPr>
+              <a:t>Post 5: </a:t>
+            </a:r>
+            <a:endParaRPr sz="1300" b="0" i="0" u="none" strike="noStrike" cap="none" dirty="0">
+              <a:solidFill>
+                <a:schemeClr val="dk1"/>
+              </a:solidFill>
+              <a:latin typeface="Montserrat SemiBold"/>
+              <a:ea typeface="Montserrat SemiBold"/>
+              <a:cs typeface="Montserrat SemiBold"/>
+              <a:sym typeface="Montserrat SemiBold"/>
+            </a:endParaRPr>
+          </a:p>
+          <a:p>
+            <a:pPr marL="0" marR="0" lvl="0" indent="0" algn="l" rtl="0">
+              <a:lnSpc>
+                <a:spcPct val="115000"/>
+              </a:lnSpc>
+              <a:spcBef>
+                <a:spcPts val="0"/>
+              </a:spcBef>
+              <a:spcAft>
+                <a:spcPts val="0"/>
+              </a:spcAft>
+              <a:buClr>
+                <a:schemeClr val="dk1"/>
+              </a:buClr>
+              <a:buSzPts val="1100"/>
+              <a:buFont typeface="Arial"/>
+              <a:buNone/>
+            </a:pPr>
+            <a:r>
+              <a:rPr lang="en-US" sz="1150" b="0" i="0" u="none" strike="noStrike" cap="none" dirty="0">
                 <a:solidFill>
                   <a:schemeClr val="dk1"/>
                 </a:solidFill>
@@ -27818,7 +27638,7 @@
                 <a:cs typeface="Montserrat"/>
                 <a:sym typeface="Montserrat"/>
               </a:rPr>
-              <a:t>Source: SIFMA Capital Markets Fact Book 2026</a:t>
+              <a:t>Getting started is easier than you think! 💡</a:t>
             </a:r>
             <a:endParaRPr sz="1300" b="0" i="0" u="none" strike="noStrike" cap="none" dirty="0">
               <a:solidFill>
@@ -27848,6 +27668,70 @@
               <a:buFont typeface="Arial"/>
               <a:buNone/>
             </a:pPr>
+            <a:r>
+              <a:rPr lang="en-US" sz="1150" b="0" i="0" u="none" strike="noStrike" cap="none" dirty="0">
+                <a:solidFill>
+                  <a:schemeClr val="dk1"/>
+                </a:solidFill>
+                <a:latin typeface="Montserrat"/>
+                <a:ea typeface="Montserrat"/>
+                <a:cs typeface="Montserrat"/>
+                <a:sym typeface="Montserrat"/>
+              </a:rPr>
+              <a:t>Explore a curated selection of U.S. stocks via the </a:t>
+            </a:r>
+            <a:r>
+              <a:rPr lang="en-US" sz="1150" b="0" i="0" u="none" strike="noStrike" cap="none" dirty="0" err="1">
+                <a:solidFill>
+                  <a:schemeClr val="dk1"/>
+                </a:solidFill>
+                <a:latin typeface="Montserrat"/>
+                <a:ea typeface="Montserrat"/>
+                <a:cs typeface="Montserrat"/>
+                <a:sym typeface="Montserrat"/>
+              </a:rPr>
+              <a:t>eMYAA</a:t>
+            </a:r>
+            <a:r>
+              <a:rPr lang="en-US" sz="1150" b="0" i="0" u="none" strike="noStrike" cap="none" dirty="0">
+                <a:solidFill>
+                  <a:schemeClr val="dk1"/>
+                </a:solidFill>
+                <a:latin typeface="Montserrat"/>
+                <a:ea typeface="Montserrat"/>
+                <a:cs typeface="Montserrat"/>
+                <a:sym typeface="Montserrat"/>
+              </a:rPr>
+              <a:t> app, with a minimum deposit starting at just $50</a:t>
+            </a:r>
+            <a:endParaRPr sz="1300" b="0" i="0" u="none" strike="noStrike" cap="none" dirty="0">
+              <a:solidFill>
+                <a:schemeClr val="dk1"/>
+              </a:solidFill>
+              <a:latin typeface="Montserrat"/>
+              <a:ea typeface="Montserrat"/>
+              <a:cs typeface="Montserrat"/>
+              <a:sym typeface="Montserrat"/>
+            </a:endParaRPr>
+          </a:p>
+          <a:p>
+            <a:pPr marL="0" marR="0" lvl="0" indent="0" algn="l" rtl="0">
+              <a:lnSpc>
+                <a:spcPct val="115000"/>
+              </a:lnSpc>
+              <a:spcBef>
+                <a:spcPts val="0"/>
+              </a:spcBef>
+              <a:spcAft>
+                <a:spcPts val="0"/>
+              </a:spcAft>
+              <a:buClr>
+                <a:schemeClr val="dk1"/>
+              </a:buClr>
+              <a:buSzPts val="1100"/>
+              <a:buFont typeface="Arial"/>
+              <a:buNone/>
+            </a:pPr>
             <a:endParaRPr sz="1300" b="0" i="0" u="none" strike="noStrike" cap="none" dirty="0">
               <a:solidFill>
                 <a:schemeClr val="dk1"/>
@@ -27877,7 +27761,7 @@
               <a:buNone/>
             </a:pPr>
             <a:r>
-              <a:rPr lang="en-US" sz="1300" b="0" i="0" u="none" strike="noStrike" cap="none" dirty="0">
+              <a:rPr lang="en-US" sz="1150" b="0" i="0" u="none" strike="noStrike" cap="none" dirty="0">
                 <a:solidFill>
                   <a:schemeClr val="dk1"/>
                 </a:solidFill>
@@ -27886,7 +27770,7 @@
                 <a:cs typeface="Montserrat SemiBold"/>
                 <a:sym typeface="Montserrat SemiBold"/>
               </a:rPr>
-              <a:t>Post 4: </a:t>
+              <a:t>Footer (on every slide):</a:t>
             </a:r>
             <a:endParaRPr sz="1300" b="0" i="0" u="none" strike="noStrike" cap="none" dirty="0">
               <a:solidFill>
@@ -27917,7 +27801,7 @@
               <a:buNone/>
             </a:pPr>
             <a:r>
-              <a:rPr lang="en-US" sz="1300" b="0" i="0" u="none" strike="noStrike" cap="none" dirty="0">
+              <a:rPr lang="en-US" sz="1150" b="0" i="1" u="none" strike="noStrike" cap="none" dirty="0">
                 <a:solidFill>
                   <a:schemeClr val="dk1"/>
                 </a:solidFill>
@@ -27926,219 +27810,7 @@
                 <a:cs typeface="Montserrat"/>
                 <a:sym typeface="Montserrat"/>
               </a:rPr>
-              <a:t>Diverse Investment Options 🏢</a:t>
-            </a:r>
-            <a:endParaRPr sz="1300" b="0" i="0" u="none" strike="noStrike" cap="none" dirty="0">
-              <a:solidFill>
-                <a:schemeClr val="dk1"/>
-              </a:solidFill>
-              <a:latin typeface="Montserrat"/>
-              <a:ea typeface="Montserrat"/>
-              <a:cs typeface="Montserrat"/>
-              <a:sym typeface="Montserrat"/>
-            </a:endParaRPr>
-          </a:p>
-          <a:p>
-            <a:pPr marL="0" marR="0" lvl="0" indent="0" algn="l" rtl="0">
-              <a:lnSpc>
-                <a:spcPct val="115000"/>
-              </a:lnSpc>
-              <a:spcBef>
-                <a:spcPts val="0"/>
-              </a:spcBef>
-              <a:spcAft>
-                <a:spcPts val="0"/>
-              </a:spcAft>
-              <a:buClr>
-                <a:schemeClr val="dk1"/>
-              </a:buClr>
-              <a:buSzPts val="1100"/>
-              <a:buFont typeface="Arial"/>
-              <a:buNone/>
-            </a:pPr>
-            <a:r>
-              <a:rPr lang="en-US" sz="1300" b="0" i="0" u="none" strike="noStrike" cap="none" dirty="0">
-                <a:solidFill>
-                  <a:schemeClr val="dk1"/>
-                </a:solidFill>
-                <a:latin typeface="Montserrat"/>
-                <a:ea typeface="Montserrat"/>
-                <a:cs typeface="Montserrat"/>
-                <a:sym typeface="Montserrat"/>
-              </a:rPr>
-              <a:t>More than 5,500 companies are listed on the New York Stock Exchange (NYSE) and NASDAQ. The top 10 companies in the S&amp;P 500 index make up approximately 38% of the index's weight.</a:t>
-            </a:r>
-            <a:endParaRPr sz="1300" b="0" i="0" u="none" strike="noStrike" cap="none" dirty="0">
-              <a:solidFill>
-                <a:schemeClr val="dk1"/>
-              </a:solidFill>
-              <a:latin typeface="Montserrat"/>
-              <a:ea typeface="Montserrat"/>
-              <a:cs typeface="Montserrat"/>
-              <a:sym typeface="Montserrat"/>
-            </a:endParaRPr>
-          </a:p>
-          <a:p>
-            <a:pPr marL="0" marR="0" lvl="0" indent="0" algn="l" rtl="0">
-              <a:lnSpc>
-                <a:spcPct val="115000"/>
-              </a:lnSpc>
-              <a:spcBef>
-                <a:spcPts val="0"/>
-              </a:spcBef>
-              <a:spcAft>
-                <a:spcPts val="0"/>
-              </a:spcAft>
-              <a:buClr>
-                <a:schemeClr val="dk1"/>
-              </a:buClr>
-              <a:buSzPts val="1100"/>
-              <a:buFont typeface="Arial"/>
-              <a:buNone/>
-            </a:pPr>
-            <a:endParaRPr sz="1300" b="0" i="0" u="none" strike="noStrike" cap="none" dirty="0">
-              <a:solidFill>
-                <a:schemeClr val="dk1"/>
-              </a:solidFill>
-              <a:latin typeface="Montserrat SemiBold"/>
-              <a:ea typeface="Montserrat SemiBold"/>
-              <a:cs typeface="Montserrat SemiBold"/>
-              <a:sym typeface="Montserrat SemiBold"/>
-            </a:endParaRPr>
-          </a:p>
-          <a:p>
-            <a:pPr marL="0" marR="0" lvl="0" indent="0" algn="l" rtl="0">
-              <a:lnSpc>
-                <a:spcPct val="115000"/>
-              </a:lnSpc>
-              <a:spcBef>
-                <a:spcPts val="0"/>
-              </a:spcBef>
-              <a:spcAft>
-                <a:spcPts val="0"/>
-              </a:spcAft>
-              <a:buClr>
-                <a:schemeClr val="dk1"/>
-              </a:buClr>
-              <a:buSzPts val="1100"/>
-              <a:buFont typeface="Arial"/>
-              <a:buNone/>
-            </a:pPr>
-            <a:r>
-              <a:rPr lang="en-US" sz="1300" b="0" i="0" u="none" strike="noStrike" cap="none" dirty="0">
-                <a:solidFill>
-                  <a:schemeClr val="dk1"/>
-                </a:solidFill>
-                <a:latin typeface="Montserrat SemiBold"/>
-                <a:ea typeface="Montserrat SemiBold"/>
-                <a:cs typeface="Montserrat SemiBold"/>
-                <a:sym typeface="Montserrat SemiBold"/>
-              </a:rPr>
-              <a:t>Post 5: </a:t>
-            </a:r>
-            <a:endParaRPr sz="1300" b="0" i="0" u="none" strike="noStrike" cap="none" dirty="0">
-              <a:solidFill>
-                <a:schemeClr val="dk1"/>
-              </a:solidFill>
-              <a:latin typeface="Montserrat SemiBold"/>
-              <a:ea typeface="Montserrat SemiBold"/>
-              <a:cs typeface="Montserrat SemiBold"/>
-              <a:sym typeface="Montserrat SemiBold"/>
-            </a:endParaRPr>
-          </a:p>
-          <a:p>
-            <a:pPr marL="0" marR="0" lvl="0" indent="0" algn="l" rtl="0">
-              <a:lnSpc>
-                <a:spcPct val="115000"/>
-              </a:lnSpc>
-              <a:spcBef>
-                <a:spcPts val="0"/>
-              </a:spcBef>
-              <a:spcAft>
-                <a:spcPts val="0"/>
-              </a:spcAft>
-              <a:buClr>
-                <a:schemeClr val="dk1"/>
-              </a:buClr>
-              <a:buSzPts val="1100"/>
-              <a:buFont typeface="Arial"/>
-              <a:buNone/>
-            </a:pPr>
-            <a:r>
-              <a:rPr lang="en-US" sz="1300" b="0" i="0" u="none" strike="noStrike" cap="none" dirty="0">
-                <a:solidFill>
-                  <a:schemeClr val="dk1"/>
-                </a:solidFill>
-                <a:latin typeface="Montserrat"/>
-                <a:ea typeface="Montserrat"/>
-                <a:cs typeface="Montserrat"/>
-                <a:sym typeface="Montserrat"/>
-              </a:rPr>
-              <a:t>Getting started is easier than you think! 💡</a:t>
-            </a:r>
-            <a:endParaRPr sz="1300" b="0" i="0" u="none" strike="noStrike" cap="none" dirty="0">
-              <a:solidFill>
-                <a:schemeClr val="dk1"/>
-              </a:solidFill>
-              <a:latin typeface="Montserrat"/>
-              <a:ea typeface="Montserrat"/>
-              <a:cs typeface="Montserrat"/>
-              <a:sym typeface="Montserrat"/>
-            </a:endParaRPr>
-          </a:p>
-          <a:p>
-            <a:pPr marL="0" marR="0" lvl="0" indent="0" algn="l" rtl="0">
-              <a:lnSpc>
-                <a:spcPct val="115000"/>
-              </a:lnSpc>
-              <a:spcBef>
-                <a:spcPts val="0"/>
-              </a:spcBef>
-              <a:spcAft>
-                <a:spcPts val="0"/>
-              </a:spcAft>
-              <a:buClr>
-                <a:schemeClr val="dk1"/>
-              </a:buClr>
-              <a:buSzPts val="1100"/>
-              <a:buFont typeface="Arial"/>
-              <a:buNone/>
-            </a:pPr>
-            <a:r>
-              <a:rPr lang="en-US" sz="1300" b="0" i="0" u="none" strike="noStrike" cap="none" dirty="0">
-                <a:solidFill>
-                  <a:schemeClr val="dk1"/>
-                </a:solidFill>
-                <a:latin typeface="Montserrat"/>
-                <a:ea typeface="Montserrat"/>
-                <a:cs typeface="Montserrat"/>
-                <a:sym typeface="Montserrat"/>
-              </a:rPr>
-              <a:t>Explore a curated selection of U.S. stocks via the </a:t>
-            </a:r>
-            <a:r>
-              <a:rPr lang="en-US" sz="1300" b="0" i="0" u="none" strike="noStrike" cap="none" dirty="0" err="1">
-                <a:solidFill>
-                  <a:schemeClr val="dk1"/>
-                </a:solidFill>
-                <a:latin typeface="Montserrat"/>
-                <a:ea typeface="Montserrat"/>
-                <a:cs typeface="Montserrat"/>
-                <a:sym typeface="Montserrat"/>
-              </a:rPr>
-              <a:t>eMYAA</a:t>
-            </a:r>
-            <a:r>
-              <a:rPr lang="en-US" sz="1300" b="0" i="0" u="none" strike="noStrike" cap="none" dirty="0">
-                <a:solidFill>
-                  <a:schemeClr val="dk1"/>
-                </a:solidFill>
-                <a:latin typeface="Montserrat"/>
-                <a:ea typeface="Montserrat"/>
-                <a:cs typeface="Montserrat"/>
-                <a:sym typeface="Montserrat"/>
-              </a:rPr>
-              <a:t> app, with a minimum deposit starting at just $50</a:t>
+              <a:t>Source: SIFMA Capital Markets Fact Book 2026. Data as of 2025. For information only, not investment advice.</a:t>
             </a:r>
             <a:endParaRPr sz="1300" b="0" i="0" u="none" strike="noStrike" cap="none" dirty="0">
               <a:solidFill>

</xml_diff>

<commit_message>
Remove all review comments from the October calendar V3 for the agency
Co-Authored-By: Claude Opus 5.5 <noreply@anthropic.com>
Claude-Session: https://claude.ai/code/session_01SNf1Edf2HMYqmZpheYf6i6
</commit_message>
<xml_diff>
--- a/emyaa-ceo-deck/output/content-calendar/Content_Calendar_OCT_2026_V3_-_eMYAA.pptx
+++ b/emyaa-ceo-deck/output/content-calendar/Content_Calendar_OCT_2026_V3_-_eMYAA.pptx
@@ -349,209 +349,6 @@
     </p:ext>
   </p:extLst>
 </p:presentation>
-</file>
-
-<file path=ppt/authors.xml><?xml version="1.0" encoding="utf-8"?>
-<p188:authorLst xmlns:a="http://schemas.openxmlformats.org/drawingml/2006/main" xmlns:r="http://schemas.openxmlformats.org/officeDocument/2006/relationships" xmlns:p188="http://schemas.microsoft.com/office/powerpoint/2018/8/main">
-  <p188:author id="{18E71D12-D815-3F05-8FC5-BC99AAF91F62}" name="Eman Mahdi Almansoor" initials="EM" userId="S::ealmansoor@ajyadcapital.com::d4a875a7-e2ef-48bf-8b87-3401686c020e" providerId="AD"/>
-</p188:authorLst>
-</file>
-
-<file path=ppt/comments/modernComment_103_0.xml><?xml version="1.0" encoding="utf-8"?>
-<p188:cmLst xmlns:a="http://schemas.openxmlformats.org/drawingml/2006/main" xmlns:r="http://schemas.openxmlformats.org/officeDocument/2006/relationships" xmlns:p188="http://schemas.microsoft.com/office/powerpoint/2018/8/main">
-  <p188:cm id="{8120C9AF-CB75-4A06-A6DD-7F4D6D7B6D52}" authorId="{18E71D12-D815-3F05-8FC5-BC99AAF91F62}" created="2026-09-30T13:49:50.519">
-    <ac:txMkLst xmlns:ac="http://schemas.microsoft.com/office/drawing/2013/main/command">
-      <pc:docMk xmlns:pc="http://schemas.microsoft.com/office/powerpoint/2013/main/command"/>
-      <pc:sldMk xmlns:pc="http://schemas.microsoft.com/office/powerpoint/2013/main/command" cId="0" sldId="259"/>
-      <ac:spMk id="52" creationId="{00000000-0000-0000-0000-000000000000}"/>
-      <ac:txMk cp="506" len="115">
-        <ac:context len="819" hash="2385309986"/>
-      </ac:txMk>
-    </ac:txMkLst>
-    <p188:pos x="7739992" y="4005348"/>
-    <p188:txBody>
-      <a:bodyPr/>
-      <a:lstStyle/>
-      <a:p>
-        <a:r>
-          <a:rPr lang="en-US"/>
-          <a:t>SPUS tracks a Shari'ah-compliant index built from the S&amp;P 500 universe, applying specific Shari'ah screening criteria.</a:t>
-        </a:r>
-      </a:p>
-    </p188:txBody>
-  </p188:cm>
-  <p188:cm id="{A9A9BF2E-DD92-4171-886D-D5B5E0335092}" authorId="{18E71D12-D815-3F05-8FC5-BC99AAF91F62}" created="2026-10-01T06:44:58.012">
-    <ac:txMkLst xmlns:ac="http://schemas.microsoft.com/office/drawing/2013/main/command">
-      <pc:docMk xmlns:pc="http://schemas.microsoft.com/office/powerpoint/2013/main/command"/>
-      <pc:sldMk xmlns:pc="http://schemas.microsoft.com/office/powerpoint/2013/main/command" cId="0" sldId="259"/>
-      <ac:spMk id="52" creationId="{00000000-0000-0000-0000-000000000000}"/>
-      <ac:txMk cp="70" len="26">
-        <ac:context len="819" hash="2385309986"/>
-      </ac:txMk>
-    </ac:txMkLst>
-    <p188:pos x="2094103" y="921906"/>
-    <p188:txBody>
-      <a:bodyPr/>
-      <a:lstStyle/>
-      <a:p>
-        <a:r>
-          <a:rPr lang="en-US"/>
-          <a:t>Let’s say: Which one fits my investment goals?</a:t>
-        </a:r>
-      </a:p>
-    </p188:txBody>
-  </p188:cm>
-</p188:cmLst>
-</file>
-
-<file path=ppt/comments/modernComment_106_0.xml><?xml version="1.0" encoding="utf-8"?>
-<p188:cmLst xmlns:a="http://schemas.openxmlformats.org/drawingml/2006/main" xmlns:r="http://schemas.openxmlformats.org/officeDocument/2006/relationships" xmlns:p188="http://schemas.microsoft.com/office/powerpoint/2018/8/main">
-  <p188:cm id="{56071635-47B9-49A1-B4AC-4F3E75645E13}" authorId="{18E71D12-D815-3F05-8FC5-BC99AAF91F62}" created="2026-09-30T13:57:18.161">
-    <ac:txMkLst xmlns:ac="http://schemas.microsoft.com/office/drawing/2013/main/command">
-      <pc:docMk xmlns:pc="http://schemas.microsoft.com/office/powerpoint/2013/main/command"/>
-      <pc:sldMk xmlns:pc="http://schemas.microsoft.com/office/powerpoint/2013/main/command" cId="0" sldId="262"/>
-      <ac:spMk id="90" creationId="{00000000-0000-0000-0000-000000000000}"/>
-      <ac:txMk cp="115" len="81">
-        <ac:context len="793" hash="703458732"/>
-      </ac:txMk>
-    </ac:txMkLst>
-    <p188:pos x="6570410" y="1412490"/>
-    <p188:txBody>
-      <a:bodyPr/>
-      <a:lstStyle/>
-      <a:p>
-        <a:r>
-          <a:rPr lang="en-US"/>
-          <a:t>I like the ovrall idea and the flow. However, I think we should change it to: U.S. equity markets represented 43.7% of global equity market capitalization in 2025. according to https://www.sifma.org/news/blog/2026-capital-markets-fact-book-key-findings</a:t>
-        </a:r>
-      </a:p>
-    </p188:txBody>
-  </p188:cm>
-  <p188:cm id="{2554342F-25B9-4CF6-892E-8DDCF0DF2C90}" authorId="{18E71D12-D815-3F05-8FC5-BC99AAF91F62}" created="2026-09-30T13:58:01.712">
-    <ac:txMkLst xmlns:ac="http://schemas.microsoft.com/office/drawing/2013/main/command">
-      <pc:docMk xmlns:pc="http://schemas.microsoft.com/office/powerpoint/2013/main/command"/>
-      <pc:sldMk xmlns:pc="http://schemas.microsoft.com/office/powerpoint/2013/main/command" cId="0" sldId="262"/>
-      <ac:spMk id="90" creationId="{00000000-0000-0000-0000-000000000000}"/>
-      <ac:txMk cp="236" len="73">
-        <ac:context len="793" hash="703458732"/>
-      </ac:txMk>
-    </ac:txMkLst>
-    <p188:pos x="5804866" y="2326890"/>
-    <p188:replyLst>
-      <p188:reply id="{9A2898C2-FEFF-46E8-A0E0-F103EAAD54A5}" authorId="{18E71D12-D815-3F05-8FC5-BC99AAF91F62}" created="2026-10-01T06:37:09.958">
-        <p188:txBody>
-          <a:bodyPr/>
-          <a:lstStyle/>
-          <a:p>
-            <a:r>
-              <a:rPr lang="en-US"/>
-              <a:t>Or we can say, last year</a:t>
-            </a:r>
-          </a:p>
-        </p188:txBody>
-      </p188:reply>
-    </p188:replyLst>
-    <p188:txBody>
-      <a:bodyPr/>
-      <a:lstStyle/>
-      <a:p>
-        <a:r>
-          <a:rPr lang="en-US"/>
-          <a:t>Same goes here: U.S. equity market capitalization stood at $68.9 trillion in 2025.</a:t>
-        </a:r>
-      </a:p>
-    </p188:txBody>
-  </p188:cm>
-  <p188:cm id="{F5EAE6B0-AC99-4154-A8F9-972AC58CE720}" authorId="{18E71D12-D815-3F05-8FC5-BC99AAF91F62}" created="2026-10-01T06:45:54.091">
-    <ac:txMkLst xmlns:ac="http://schemas.microsoft.com/office/drawing/2013/main/command">
-      <pc:docMk xmlns:pc="http://schemas.microsoft.com/office/powerpoint/2013/main/command"/>
-      <pc:sldMk xmlns:pc="http://schemas.microsoft.com/office/powerpoint/2013/main/command" cId="0" sldId="262"/>
-      <ac:spMk id="90" creationId="{00000000-0000-0000-0000-000000000000}"/>
-      <ac:txMk cp="92" len="20">
-        <ac:context len="793" hash="703458732"/>
-      </ac:txMk>
-    </ac:txMkLst>
-    <p188:pos x="1665470" y="1187925"/>
-    <p188:txBody>
-      <a:bodyPr/>
-      <a:lstStyle/>
-      <a:p>
-        <a:r>
-          <a:rPr lang="en-US"/>
-          <a:t>Lets say: The World’s Largest Equity Market</a:t>
-        </a:r>
-      </a:p>
-    </p188:txBody>
-  </p188:cm>
-</p188:cmLst>
-</file>
-
-<file path=ppt/comments/modernComment_108_0.xml><?xml version="1.0" encoding="utf-8"?>
-<p188:cmLst xmlns:a="http://schemas.openxmlformats.org/drawingml/2006/main" xmlns:r="http://schemas.openxmlformats.org/officeDocument/2006/relationships" xmlns:p188="http://schemas.microsoft.com/office/powerpoint/2018/8/main">
-  <p188:cm id="{63974FDA-05E3-4618-A732-F47A29EB11E5}" authorId="{18E71D12-D815-3F05-8FC5-BC99AAF91F62}" created="2026-09-30T13:58:49.648">
-    <ac:txMkLst xmlns:ac="http://schemas.microsoft.com/office/drawing/2013/main/command">
-      <pc:docMk xmlns:pc="http://schemas.microsoft.com/office/powerpoint/2013/main/command"/>
-      <pc:sldMk xmlns:pc="http://schemas.microsoft.com/office/powerpoint/2013/main/command" cId="0" sldId="264"/>
-      <ac:spMk id="115" creationId="{00000000-0000-0000-0000-000000000000}"/>
-      <ac:txMk cp="30" len="4">
-        <ac:context len="315" hash="3787464096"/>
-      </ac:txMk>
-    </ac:txMkLst>
-    <p188:pos x="2625664" y="739318"/>
-    <p188:txBody>
-      <a:bodyPr/>
-      <a:lstStyle/>
-      <a:p>
-        <a:r>
-          <a:rPr lang="en-US"/>
-          <a:t>buy</a:t>
-        </a:r>
-      </a:p>
-    </p188:txBody>
-  </p188:cm>
-  <p188:cm id="{CC84E90B-ACFF-4558-AAFC-32F94738201A}" authorId="{18E71D12-D815-3F05-8FC5-BC99AAF91F62}" created="2026-09-30T13:59:09.749">
-    <ac:txMkLst xmlns:ac="http://schemas.microsoft.com/office/drawing/2013/main/command">
-      <pc:docMk xmlns:pc="http://schemas.microsoft.com/office/powerpoint/2013/main/command"/>
-      <pc:sldMk xmlns:pc="http://schemas.microsoft.com/office/powerpoint/2013/main/command" cId="0" sldId="264"/>
-      <ac:spMk id="115" creationId="{00000000-0000-0000-0000-000000000000}"/>
-      <ac:txMk cp="264" len="4">
-        <ac:context len="315" hash="3787464096"/>
-      </ac:txMk>
-    </ac:txMkLst>
-    <p188:pos x="2870213" y="3195439"/>
-    <p188:txBody>
-      <a:bodyPr/>
-      <a:lstStyle/>
-      <a:p>
-        <a:r>
-          <a:rPr lang="en-US"/>
-          <a:t>buy</a:t>
-        </a:r>
-      </a:p>
-    </p188:txBody>
-  </p188:cm>
-  <p188:cm id="{A3B6900D-15F4-440D-9620-E996B992D7F5}" authorId="{18E71D12-D815-3F05-8FC5-BC99AAF91F62}" created="2026-10-01T06:40:43.901">
-    <ac:txMkLst xmlns:ac="http://schemas.microsoft.com/office/drawing/2013/main/command">
-      <pc:docMk xmlns:pc="http://schemas.microsoft.com/office/powerpoint/2013/main/command"/>
-      <pc:sldMk xmlns:pc="http://schemas.microsoft.com/office/powerpoint/2013/main/command" cId="0" sldId="264"/>
-      <ac:spMk id="117" creationId="{00000000-0000-0000-0000-000000000000}"/>
-      <ac:txMk cp="301" len="9">
-        <ac:context len="396" hash="2170607440"/>
-      </ac:txMk>
-    </ac:txMkLst>
-    <p188:pos x="1948446" y="2768484"/>
-    <p188:txBody>
-      <a:bodyPr/>
-      <a:lstStyle/>
-      <a:p>
-        <a:r>
-          <a:rPr lang="en-US"/>
-          <a:t>Unfortunately we do not have real time data</a:t>
-        </a:r>
-      </a:p>
-    </p188:txBody>
-  </p188:cm>
-</p188:cmLst>
 </file>
 
 <file path=ppt/notesMasters/notesMaster1.xml><?xml version="1.0" encoding="utf-8"?>
@@ -21690,11 +21487,6 @@
   <p:clrMapOvr>
     <a:masterClrMapping/>
   </p:clrMapOvr>
-  <p:extLst>
-    <p:ext uri="{6950BFC3-D8DA-4A85-94F7-54DA5524770B}">
-      <p188:commentRel xmlns:p188="http://schemas.microsoft.com/office/powerpoint/2018/8/main" r:id="rId3"/>
-    </p:ext>
-  </p:extLst>
 </p:sld>
 </file>
 
@@ -27829,11 +27621,6 @@
   <p:clrMapOvr>
     <a:masterClrMapping/>
   </p:clrMapOvr>
-  <p:extLst>
-    <p:ext uri="{6950BFC3-D8DA-4A85-94F7-54DA5524770B}">
-      <p188:commentRel xmlns:p188="http://schemas.microsoft.com/office/powerpoint/2018/8/main" r:id="rId3"/>
-    </p:ext>
-  </p:extLst>
 </p:sld>
 </file>
 
@@ -31119,11 +30906,6 @@
   <p:clrMapOvr>
     <a:masterClrMapping/>
   </p:clrMapOvr>
-  <p:extLst>
-    <p:ext uri="{6950BFC3-D8DA-4A85-94F7-54DA5524770B}">
-      <p188:commentRel xmlns:p188="http://schemas.microsoft.com/office/powerpoint/2018/8/main" r:id="rId3"/>
-    </p:ext>
-  </p:extLst>
 </p:sld>
 </file>
 

</xml_diff>